<commit_message>
feat: sincronización Athenasys + mejoras UI y excluir proyecto inventario-ti
- Nueva feature de sincronización desde BD Athenasys (sync.routes.js, athenasys-sync.service.js, página Sync.jsx) hacia previta_kronos
- Mejoras y ajustes acumulados en frontend (Sucursales, Usuarios, Admin, contextos, temas, etc.)
- Ajustes en backend (server.js, db.js con pool secundario Athenasys, registros.routes.js)
- .gitignore: excluir carpeta externa jestradaProyectosathenasys/ (proyecto inventario-ti anidado por accidente, ajeno a KronOS)

Co-Authored-By: Claude Opus 4.8 <noreply@anthropic.com>
</commit_message>
<xml_diff>
--- a/docs/KronOS_Maquetas_Ejecutiva_2026.pptx
+++ b/docs/KronOS_Maquetas_Ejecutiva_2026.pptx
@@ -4,6 +4,9 @@
   <p:sldMasterIdLst>
     <p:sldMasterId id="2147483648" r:id="rId1"/>
   </p:sldMasterIdLst>
+  <p:notesMasterIdLst>
+    <p:notesMasterId r:id="rId19"/>
+  </p:notesMasterIdLst>
   <p:sldIdLst>
     <p:sldId id="256" r:id="rId2"/>
     <p:sldId id="257" r:id="rId3"/>
@@ -23,10 +26,7 @@
     <p:sldId id="271" r:id="rId17"/>
     <p:sldId id="272" r:id="rId18"/>
   </p:sldIdLst>
-  <p:notesMasterIdLst>
-    <p:notesMasterId r:id="rId19"/>
-  </p:notesMasterIdLst>
-  <p:sldSz cx="9144000" cy="5143500"/>
+  <p:sldSz cx="9144000" cy="5143500" type="screen16x9"/>
   <p:notesSz cx="5143500" cy="9144000"/>
   <p:defaultTextStyle>
     <a:lvl1pPr marL="0" algn="l" defTabSz="914400" rtl="0" eaLnBrk="1" latinLnBrk="0" hangingPunct="1">
@@ -120,6 +120,11 @@
       </a:defRPr>
     </a:lvl9pPr>
   </p:defaultTextStyle>
+  <p:extLst>
+    <p:ext uri="{EFAFB233-063F-42B5-8137-9DF3F51BA10A}">
+      <p15:sldGuideLst xmlns:p15="http://schemas.microsoft.com/office/powerpoint/2012/main"/>
+    </p:ext>
+  </p:extLst>
 </p:presentation>
 </file>
 
@@ -145,234 +150,10 @@
           <a:chExt cx="0" cy="0"/>
         </a:xfrm>
       </p:grpSpPr>
-      <p:sp>
-        <p:nvSpPr>
-          <p:cNvPr id="2" name="Header Placeholder 1"/>
-          <p:cNvSpPr>
-            <a:spLocks noGrp="1"/>
-          </p:cNvSpPr>
-          <p:nvPr>
-            <p:ph type="hdr" sz="quarter"/>
-          </p:nvPr>
-        </p:nvSpPr>
-        <p:spPr>
-          <a:xfrm>
-            <a:off x="0" y="0"/>
-            <a:ext cx="2971800" cy="458788"/>
-          </a:xfrm>
-          <a:prstGeom prst="rect">
-            <a:avLst/>
-          </a:prstGeom>
-        </p:spPr>
-        <p:txBody>
-          <a:bodyPr vert="horz" lIns="91440" tIns="45720" rIns="91440" bIns="45720" rtlCol="0"/>
-          <a:lstStyle>
-            <a:lvl1pPr algn="l">
-              <a:defRPr sz="1200"/>
-            </a:lvl1pPr>
-          </a:lstStyle>
-          <a:p>
-            <a:endParaRPr lang="en-US"/>
-          </a:p>
-        </p:txBody>
-      </p:sp>
-      <p:sp>
-        <p:nvSpPr>
-          <p:cNvPr id="3" name="Date Placeholder 2"/>
-          <p:cNvSpPr>
-            <a:spLocks noGrp="1"/>
-          </p:cNvSpPr>
-          <p:nvPr>
-            <p:ph type="dt" idx="1"/>
-          </p:nvPr>
-        </p:nvSpPr>
-        <p:spPr>
-          <a:xfrm>
-            <a:off x="3884613" y="0"/>
-            <a:ext cx="2971800" cy="458788"/>
-          </a:xfrm>
-          <a:prstGeom prst="rect">
-            <a:avLst/>
-          </a:prstGeom>
-        </p:spPr>
-        <p:txBody>
-          <a:bodyPr vert="horz" lIns="91440" tIns="45720" rIns="91440" bIns="45720" rtlCol="0"/>
-          <a:lstStyle>
-            <a:lvl1pPr algn="r">
-              <a:defRPr sz="1200"/>
-            </a:lvl1pPr>
-          </a:lstStyle>
-          <a:p>
-            <a:fld id="{5282F153-3F37-0F45-9E97-73ACFA13230C}" type="datetimeFigureOut">
-              <a:rPr lang="en-US"/>
-              <a:t>7/23/19</a:t>
-            </a:fld>
-            <a:endParaRPr lang="en-US"/>
-          </a:p>
-        </p:txBody>
-      </p:sp>
-      <p:sp>
-        <p:nvSpPr>
-          <p:cNvPr id="4" name="Slide Image Placeholder 3"/>
-          <p:cNvSpPr>
-            <a:spLocks noGrp="1" noRot="1" noChangeAspect="1"/>
-          </p:cNvSpPr>
-          <p:nvPr>
-            <p:ph type="sldImg" idx="2"/>
-          </p:nvPr>
-        </p:nvSpPr>
-        <p:spPr>
-          <a:xfrm>
-            <a:off x="685800" y="1143000"/>
-            <a:ext cx="5486400" cy="3086100"/>
-          </a:xfrm>
-          <a:prstGeom prst="rect">
-            <a:avLst/>
-          </a:prstGeom>
-          <a:noFill/>
-          <a:ln w="12700">
-            <a:solidFill>
-              <a:prstClr val="black"/>
-            </a:solidFill>
-          </a:ln>
-        </p:spPr>
-        <p:txBody>
-          <a:bodyPr vert="horz" lIns="91440" tIns="45720" rIns="91440" bIns="45720" rtlCol="0" anchor="ctr"/>
-          <a:lstStyle/>
-          <a:p>
-            <a:endParaRPr lang="en-US"/>
-          </a:p>
-        </p:txBody>
-      </p:sp>
-      <p:sp>
-        <p:nvSpPr>
-          <p:cNvPr id="5" name="Notes Placeholder 4"/>
-          <p:cNvSpPr>
-            <a:spLocks noGrp="1"/>
-          </p:cNvSpPr>
-          <p:nvPr>
-            <p:ph type="body" sz="quarter" idx="3"/>
-          </p:nvPr>
-        </p:nvSpPr>
-        <p:spPr>
-          <a:xfrm>
-            <a:off x="685800" y="4400550"/>
-            <a:ext cx="5486400" cy="3600450"/>
-          </a:xfrm>
-          <a:prstGeom prst="rect">
-            <a:avLst/>
-          </a:prstGeom>
-        </p:spPr>
-        <p:txBody>
-          <a:bodyPr vert="horz" lIns="91440" tIns="45720" rIns="91440" bIns="45720" rtlCol="0"/>
-          <a:lstStyle/>
-          <a:p>
-            <a:pPr lvl="0"/>
-            <a:r>
-              <a:rPr lang="en-US"/>
-              <a:t>Click to edit Master text styles</a:t>
-            </a:r>
-          </a:p>
-          <a:p>
-            <a:pPr lvl="1"/>
-            <a:r>
-              <a:rPr lang="en-US"/>
-              <a:t>Second level</a:t>
-            </a:r>
-          </a:p>
-          <a:p>
-            <a:pPr lvl="2"/>
-            <a:r>
-              <a:rPr lang="en-US"/>
-              <a:t>Third level</a:t>
-            </a:r>
-          </a:p>
-          <a:p>
-            <a:pPr lvl="3"/>
-            <a:r>
-              <a:rPr lang="en-US"/>
-              <a:t>Fourth level</a:t>
-            </a:r>
-          </a:p>
-          <a:p>
-            <a:pPr lvl="4"/>
-            <a:r>
-              <a:rPr lang="en-US"/>
-              <a:t>Fifth level</a:t>
-            </a:r>
-          </a:p>
-        </p:txBody>
-      </p:sp>
-      <p:sp>
-        <p:nvSpPr>
-          <p:cNvPr id="6" name="Footer Placeholder 5"/>
-          <p:cNvSpPr>
-            <a:spLocks noGrp="1"/>
-          </p:cNvSpPr>
-          <p:nvPr>
-            <p:ph type="ftr" sz="quarter" idx="4"/>
-          </p:nvPr>
-        </p:nvSpPr>
-        <p:spPr>
-          <a:xfrm>
-            <a:off x="0" y="8685213"/>
-            <a:ext cx="2971800" cy="458787"/>
-          </a:xfrm>
-          <a:prstGeom prst="rect">
-            <a:avLst/>
-          </a:prstGeom>
-        </p:spPr>
-        <p:txBody>
-          <a:bodyPr vert="horz" lIns="91440" tIns="45720" rIns="91440" bIns="45720" rtlCol="0" anchor="b"/>
-          <a:lstStyle>
-            <a:lvl1pPr algn="l">
-              <a:defRPr sz="1200"/>
-            </a:lvl1pPr>
-          </a:lstStyle>
-          <a:p>
-            <a:endParaRPr lang="en-US"/>
-          </a:p>
-        </p:txBody>
-      </p:sp>
-      <p:sp>
-        <p:nvSpPr>
-          <p:cNvPr id="7" name="Slide Number Placeholder 6"/>
-          <p:cNvSpPr>
-            <a:spLocks noGrp="1"/>
-          </p:cNvSpPr>
-          <p:nvPr>
-            <p:ph type="sldNum" sz="quarter" idx="5"/>
-          </p:nvPr>
-        </p:nvSpPr>
-        <p:spPr>
-          <a:xfrm>
-            <a:off x="3884613" y="8685213"/>
-            <a:ext cx="2971800" cy="458787"/>
-          </a:xfrm>
-          <a:prstGeom prst="rect">
-            <a:avLst/>
-          </a:prstGeom>
-        </p:spPr>
-        <p:txBody>
-          <a:bodyPr vert="horz" lIns="91440" tIns="45720" rIns="91440" bIns="45720" rtlCol="0" anchor="b"/>
-          <a:lstStyle>
-            <a:lvl1pPr algn="r">
-              <a:defRPr sz="1200"/>
-            </a:lvl1pPr>
-          </a:lstStyle>
-          <a:p>
-            <a:fld id="{CE5E9CC1-C706-0F49-92D6-E571CC5EEA8F}" type="slidenum">
-              <a:rPr lang="en-US"/>
-              <a:t>‹#›</a:t>
-            </a:fld>
-            <a:endParaRPr lang="en-US"/>
-          </a:p>
-        </p:txBody>
-      </p:sp>
     </p:spTree>
     <p:extLst>
       <p:ext uri="{BB962C8B-B14F-4D97-AF65-F5344CB8AC3E}">
-        <p14:creationId xmlns:p14="http://schemas.microsoft.com/office/powerpoint/2010/main" val="1024086991"/>
+        <p14:creationId xmlns:p14="http://schemas.microsoft.com/office/powerpoint/2010/main" val="3136244102"/>
       </p:ext>
     </p:extLst>
   </p:cSld>
@@ -516,10 +297,6 @@
           <a:bodyPr/>
           <a:lstStyle/>
           <a:p>
-            <a:r>
-              <a:rPr lang="en-US" dirty="0"/>
-              <a:t/>
-            </a:r>
             <a:endParaRPr lang="en-US" dirty="0"/>
           </a:p>
         </p:txBody>
@@ -604,10 +381,6 @@
           <a:bodyPr/>
           <a:lstStyle/>
           <a:p>
-            <a:r>
-              <a:rPr lang="en-US" dirty="0"/>
-              <a:t/>
-            </a:r>
             <a:endParaRPr lang="en-US" dirty="0"/>
           </a:p>
         </p:txBody>
@@ -692,10 +465,6 @@
           <a:bodyPr/>
           <a:lstStyle/>
           <a:p>
-            <a:r>
-              <a:rPr lang="en-US" dirty="0"/>
-              <a:t/>
-            </a:r>
             <a:endParaRPr lang="en-US" dirty="0"/>
           </a:p>
         </p:txBody>
@@ -780,10 +549,6 @@
           <a:bodyPr/>
           <a:lstStyle/>
           <a:p>
-            <a:r>
-              <a:rPr lang="en-US" dirty="0"/>
-              <a:t/>
-            </a:r>
             <a:endParaRPr lang="en-US" dirty="0"/>
           </a:p>
         </p:txBody>
@@ -868,10 +633,6 @@
           <a:bodyPr/>
           <a:lstStyle/>
           <a:p>
-            <a:r>
-              <a:rPr lang="en-US" dirty="0"/>
-              <a:t/>
-            </a:r>
             <a:endParaRPr lang="en-US" dirty="0"/>
           </a:p>
         </p:txBody>
@@ -956,10 +717,6 @@
           <a:bodyPr/>
           <a:lstStyle/>
           <a:p>
-            <a:r>
-              <a:rPr lang="en-US" dirty="0"/>
-              <a:t/>
-            </a:r>
             <a:endParaRPr lang="en-US" dirty="0"/>
           </a:p>
         </p:txBody>
@@ -1044,10 +801,6 @@
           <a:bodyPr/>
           <a:lstStyle/>
           <a:p>
-            <a:r>
-              <a:rPr lang="en-US" dirty="0"/>
-              <a:t/>
-            </a:r>
             <a:endParaRPr lang="en-US" dirty="0"/>
           </a:p>
         </p:txBody>
@@ -1132,10 +885,6 @@
           <a:bodyPr/>
           <a:lstStyle/>
           <a:p>
-            <a:r>
-              <a:rPr lang="en-US" dirty="0"/>
-              <a:t/>
-            </a:r>
             <a:endParaRPr lang="en-US" dirty="0"/>
           </a:p>
         </p:txBody>
@@ -1220,10 +969,6 @@
           <a:bodyPr/>
           <a:lstStyle/>
           <a:p>
-            <a:r>
-              <a:rPr lang="en-US" dirty="0"/>
-              <a:t/>
-            </a:r>
             <a:endParaRPr lang="en-US" dirty="0"/>
           </a:p>
         </p:txBody>
@@ -1308,10 +1053,6 @@
           <a:bodyPr/>
           <a:lstStyle/>
           <a:p>
-            <a:r>
-              <a:rPr lang="en-US" dirty="0"/>
-              <a:t/>
-            </a:r>
             <a:endParaRPr lang="en-US" dirty="0"/>
           </a:p>
         </p:txBody>
@@ -1396,10 +1137,6 @@
           <a:bodyPr/>
           <a:lstStyle/>
           <a:p>
-            <a:r>
-              <a:rPr lang="en-US" dirty="0"/>
-              <a:t/>
-            </a:r>
             <a:endParaRPr lang="en-US" dirty="0"/>
           </a:p>
         </p:txBody>
@@ -1484,10 +1221,6 @@
           <a:bodyPr/>
           <a:lstStyle/>
           <a:p>
-            <a:r>
-              <a:rPr lang="en-US" dirty="0"/>
-              <a:t/>
-            </a:r>
             <a:endParaRPr lang="en-US" dirty="0"/>
           </a:p>
         </p:txBody>
@@ -1572,10 +1305,6 @@
           <a:bodyPr/>
           <a:lstStyle/>
           <a:p>
-            <a:r>
-              <a:rPr lang="en-US" dirty="0"/>
-              <a:t/>
-            </a:r>
             <a:endParaRPr lang="en-US" dirty="0"/>
           </a:p>
         </p:txBody>
@@ -1660,10 +1389,6 @@
           <a:bodyPr/>
           <a:lstStyle/>
           <a:p>
-            <a:r>
-              <a:rPr lang="en-US" dirty="0"/>
-              <a:t/>
-            </a:r>
             <a:endParaRPr lang="en-US" dirty="0"/>
           </a:p>
         </p:txBody>
@@ -1748,10 +1473,6 @@
           <a:bodyPr/>
           <a:lstStyle/>
           <a:p>
-            <a:r>
-              <a:rPr lang="en-US" dirty="0"/>
-              <a:t/>
-            </a:r>
             <a:endParaRPr lang="en-US" dirty="0"/>
           </a:p>
         </p:txBody>
@@ -1836,10 +1557,6 @@
           <a:bodyPr/>
           <a:lstStyle/>
           <a:p>
-            <a:r>
-              <a:rPr lang="en-US" dirty="0"/>
-              <a:t/>
-            </a:r>
             <a:endParaRPr lang="en-US" dirty="0"/>
           </a:p>
         </p:txBody>
@@ -1924,10 +1641,6 @@
           <a:bodyPr/>
           <a:lstStyle/>
           <a:p>
-            <a:r>
-              <a:rPr lang="en-US" dirty="0"/>
-              <a:t/>
-            </a:r>
             <a:endParaRPr lang="en-US" dirty="0"/>
           </a:p>
         </p:txBody>
@@ -2001,6 +1714,11 @@
 <file path=ppt/slideMasters/slideMaster1.xml><?xml version="1.0" encoding="utf-8"?>
 <p:sldMaster xmlns:a="http://schemas.openxmlformats.org/drawingml/2006/main" xmlns:r="http://schemas.openxmlformats.org/officeDocument/2006/relationships" xmlns:p="http://schemas.openxmlformats.org/presentationml/2006/main">
   <p:cSld>
+    <p:bg>
+      <p:bgRef idx="1001">
+        <a:schemeClr val="bg1"/>
+      </p:bgRef>
+    </p:bg>
     <p:spTree>
       <p:nvGrpSpPr>
         <p:cNvPr id="1" name=""/>
@@ -2283,6 +2001,7 @@
         <a:solidFill>
           <a:srgbClr val="0B0F1A"/>
         </a:solidFill>
+        <a:effectLst/>
       </p:bgPr>
     </p:bg>
     <p:spTree>
@@ -2320,11 +2039,11 @@
           <a:bodyPr wrap="square" rtlCol="0" anchor="ctr"/>
           <a:lstStyle/>
           <a:p>
-            <a:pPr indent="0" marL="0">
-              <a:buNone/>
-            </a:pPr>
-            <a:r>
-              <a:rPr lang="en-US" sz="900" b="1" spc="400" kern="0" dirty="0">
+            <a:pPr marL="0" indent="0">
+              <a:buNone/>
+            </a:pPr>
+            <a:r>
+              <a:rPr lang="en-US" sz="900" b="1" kern="0" spc="400" dirty="0">
                 <a:solidFill>
                   <a:srgbClr val="4ADE80"/>
                 </a:solidFill>
@@ -2359,7 +2078,7 @@
           <a:bodyPr wrap="square" rtlCol="0" anchor="ctr"/>
           <a:lstStyle/>
           <a:p>
-            <a:pPr algn="ctr" indent="0" marL="0">
+            <a:pPr marL="0" indent="0" algn="ctr">
               <a:buNone/>
             </a:pPr>
             <a:r>
@@ -2398,7 +2117,7 @@
           <a:bodyPr wrap="square" rtlCol="0" anchor="ctr"/>
           <a:lstStyle/>
           <a:p>
-            <a:pPr algn="ctr" indent="0" marL="0">
+            <a:pPr marL="0" indent="0" algn="ctr">
               <a:buNone/>
             </a:pPr>
             <a:r>
@@ -2437,7 +2156,7 @@
           <a:bodyPr wrap="square" rtlCol="0" anchor="ctr"/>
           <a:lstStyle/>
           <a:p>
-            <a:pPr algn="ctr" indent="0" marL="0">
+            <a:pPr marL="0" indent="0" algn="ctr">
               <a:buNone/>
             </a:pPr>
             <a:r>
@@ -2479,6 +2198,13 @@
             <a:prstDash val="solid"/>
           </a:ln>
         </p:spPr>
+        <p:txBody>
+          <a:bodyPr/>
+          <a:lstStyle/>
+          <a:p>
+            <a:endParaRPr lang="es-MX"/>
+          </a:p>
+        </p:txBody>
       </p:sp>
       <p:sp>
         <p:nvSpPr>
@@ -2504,6 +2230,13 @@
             <a:prstDash val="solid"/>
           </a:ln>
         </p:spPr>
+        <p:txBody>
+          <a:bodyPr/>
+          <a:lstStyle/>
+          <a:p>
+            <a:endParaRPr lang="es-MX"/>
+          </a:p>
+        </p:txBody>
       </p:sp>
       <p:sp>
         <p:nvSpPr>
@@ -2529,6 +2262,13 @@
             <a:prstDash val="solid"/>
           </a:ln>
         </p:spPr>
+        <p:txBody>
+          <a:bodyPr/>
+          <a:lstStyle/>
+          <a:p>
+            <a:endParaRPr lang="es-MX"/>
+          </a:p>
+        </p:txBody>
       </p:sp>
       <p:sp>
         <p:nvSpPr>
@@ -2542,9 +2282,7 @@
             <a:ext cx="658368" cy="310896"/>
           </a:xfrm>
           <a:prstGeom prst="rect">
-            <a:avLst>
-              <a:gd name="adj" fmla="val 17647"/>
-            </a:avLst>
+            <a:avLst/>
           </a:prstGeom>
           <a:solidFill>
             <a:srgbClr val="1E2A45"/>
@@ -2556,6 +2294,13 @@
             <a:prstDash val="solid"/>
           </a:ln>
         </p:spPr>
+        <p:txBody>
+          <a:bodyPr/>
+          <a:lstStyle/>
+          <a:p>
+            <a:endParaRPr lang="es-MX"/>
+          </a:p>
+        </p:txBody>
       </p:sp>
       <p:sp>
         <p:nvSpPr>
@@ -2578,7 +2323,7 @@
           <a:bodyPr wrap="square" rtlCol="0" anchor="ctr"/>
           <a:lstStyle/>
           <a:p>
-            <a:pPr algn="ctr" indent="0" marL="0">
+            <a:pPr marL="0" indent="0" algn="ctr">
               <a:buNone/>
             </a:pPr>
             <a:r>
@@ -2612,6 +2357,7 @@
         <a:solidFill>
           <a:srgbClr val="141929"/>
         </a:solidFill>
+        <a:effectLst/>
       </p:bgPr>
     </p:bg>
     <p:spTree>
@@ -2652,17 +2398,24 @@
             <a:prstDash val="solid"/>
           </a:ln>
         </p:spPr>
+        <p:txBody>
+          <a:bodyPr/>
+          <a:lstStyle/>
+          <a:p>
+            <a:endParaRPr lang="es-MX"/>
+          </a:p>
+        </p:txBody>
       </p:sp>
       <p:pic>
         <p:nvPicPr>
-          <p:cNvPr id="3" name="Image 0" descr="C:\Users\JoseRamonEstradaRend\AppData\Roaming\Claude\local-agent-mode-sessions\skills-plugin\d7d799c7-c68d-4735-9f18-5020fbbe8e77\246afd61-2015-4905-b7d3-2bf63e539570\skills\pptx\screenshots\08_horarios.jpg">    </p:cNvPr>
+          <p:cNvPr id="3" name="Image 0" descr="C:\Users\JoseRamonEstradaRend\AppData\Roaming\Claude\local-agent-mode-sessions\skills-plugin\d7d799c7-c68d-4735-9f18-5020fbbe8e77\246afd61-2015-4905-b7d3-2bf63e539570\skills\pptx\screenshots\08_horarios.jpg"/>
           <p:cNvPicPr>
             <a:picLocks noChangeAspect="1"/>
           </p:cNvPicPr>
           <p:nvPr/>
         </p:nvPicPr>
         <p:blipFill>
-          <a:blip r:embed="rId1"/>
+          <a:blip r:embed="rId3"/>
           <a:stretch>
             <a:fillRect/>
           </a:stretch>
@@ -2676,7 +2429,7 @@
             <a:avLst/>
           </a:prstGeom>
           <a:effectLst>
-            <a:outerShdw sx="100000" sy="100000" kx="0" ky="0" algn="bl" rotWithShape="0" blurRad="152400" dist="50800" dir="2700000">
+            <a:outerShdw blurRad="152400" dist="50800" dir="2700000" algn="bl" rotWithShape="0">
               <a:srgbClr val="000000">
                 <a:alpha val="55000"/>
               </a:srgbClr>
@@ -2696,9 +2449,7 @@
             <a:ext cx="384048" cy="256032"/>
           </a:xfrm>
           <a:prstGeom prst="rect">
-            <a:avLst>
-              <a:gd name="adj" fmla="val 14286"/>
-            </a:avLst>
+            <a:avLst/>
           </a:prstGeom>
           <a:solidFill>
             <a:srgbClr val="4ADE80"/>
@@ -2710,6 +2461,13 @@
             <a:prstDash val="solid"/>
           </a:ln>
         </p:spPr>
+        <p:txBody>
+          <a:bodyPr/>
+          <a:lstStyle/>
+          <a:p>
+            <a:endParaRPr lang="es-MX"/>
+          </a:p>
+        </p:txBody>
       </p:sp>
       <p:sp>
         <p:nvSpPr>
@@ -2732,7 +2490,7 @@
           <a:bodyPr wrap="square" rtlCol="0" anchor="ctr"/>
           <a:lstStyle/>
           <a:p>
-            <a:pPr algn="ctr" indent="0" marL="0">
+            <a:pPr marL="0" indent="0" algn="ctr">
               <a:buNone/>
             </a:pPr>
             <a:r>
@@ -2773,7 +2531,7 @@
           </a:bodyPr>
           <a:lstStyle/>
           <a:p>
-            <a:pPr indent="0" marL="0">
+            <a:pPr marL="0" indent="0">
               <a:buNone/>
             </a:pPr>
             <a:r>
@@ -2813,6 +2571,13 @@
             <a:prstDash val="solid"/>
           </a:ln>
         </p:spPr>
+        <p:txBody>
+          <a:bodyPr/>
+          <a:lstStyle/>
+          <a:p>
+            <a:endParaRPr lang="es-MX"/>
+          </a:p>
+        </p:txBody>
       </p:sp>
       <p:sp>
         <p:nvSpPr>
@@ -2835,7 +2600,7 @@
           <a:bodyPr wrap="square" rtlCol="0" anchor="t"/>
           <a:lstStyle/>
           <a:p>
-            <a:pPr indent="0" marL="0">
+            <a:pPr marL="0" indent="0">
               <a:buNone/>
             </a:pPr>
             <a:r>
@@ -2874,7 +2639,7 @@
           <a:bodyPr wrap="square" rtlCol="0" anchor="t"/>
           <a:lstStyle/>
           <a:p>
-            <a:pPr indent="0" marL="0">
+            <a:pPr marL="0" indent="0">
               <a:buNone/>
             </a:pPr>
             <a:r>
@@ -2913,7 +2678,7 @@
           <a:bodyPr wrap="square" rtlCol="0" anchor="t"/>
           <a:lstStyle/>
           <a:p>
-            <a:pPr indent="0" marL="0">
+            <a:pPr marL="0" indent="0">
               <a:buNone/>
             </a:pPr>
             <a:r>
@@ -2952,7 +2717,7 @@
           <a:bodyPr wrap="square" rtlCol="0" anchor="t"/>
           <a:lstStyle/>
           <a:p>
-            <a:pPr indent="0" marL="0">
+            <a:pPr marL="0" indent="0">
               <a:buNone/>
             </a:pPr>
             <a:r>
@@ -2986,6 +2751,7 @@
         <a:solidFill>
           <a:srgbClr val="141929"/>
         </a:solidFill>
+        <a:effectLst/>
       </p:bgPr>
     </p:bg>
     <p:spTree>
@@ -3026,17 +2792,24 @@
             <a:prstDash val="solid"/>
           </a:ln>
         </p:spPr>
+        <p:txBody>
+          <a:bodyPr/>
+          <a:lstStyle/>
+          <a:p>
+            <a:endParaRPr lang="es-MX"/>
+          </a:p>
+        </p:txBody>
       </p:sp>
       <p:pic>
         <p:nvPicPr>
-          <p:cNvPr id="3" name="Image 0" descr="C:\Users\JoseRamonEstradaRend\AppData\Roaming\Claude\local-agent-mode-sessions\skills-plugin\d7d799c7-c68d-4735-9f18-5020fbbe8e77\246afd61-2015-4905-b7d3-2bf63e539570\skills\pptx\screenshots\09_sucursales.jpg">    </p:cNvPr>
+          <p:cNvPr id="3" name="Image 0" descr="C:\Users\JoseRamonEstradaRend\AppData\Roaming\Claude\local-agent-mode-sessions\skills-plugin\d7d799c7-c68d-4735-9f18-5020fbbe8e77\246afd61-2015-4905-b7d3-2bf63e539570\skills\pptx\screenshots\09_sucursales.jpg"/>
           <p:cNvPicPr>
             <a:picLocks noChangeAspect="1"/>
           </p:cNvPicPr>
           <p:nvPr/>
         </p:nvPicPr>
         <p:blipFill>
-          <a:blip r:embed="rId1"/>
+          <a:blip r:embed="rId3"/>
           <a:stretch>
             <a:fillRect/>
           </a:stretch>
@@ -3050,7 +2823,7 @@
             <a:avLst/>
           </a:prstGeom>
           <a:effectLst>
-            <a:outerShdw sx="100000" sy="100000" kx="0" ky="0" algn="bl" rotWithShape="0" blurRad="152400" dist="50800" dir="2700000">
+            <a:outerShdw blurRad="152400" dist="50800" dir="2700000" algn="bl" rotWithShape="0">
               <a:srgbClr val="000000">
                 <a:alpha val="55000"/>
               </a:srgbClr>
@@ -3070,9 +2843,7 @@
             <a:ext cx="384048" cy="256032"/>
           </a:xfrm>
           <a:prstGeom prst="rect">
-            <a:avLst>
-              <a:gd name="adj" fmla="val 14286"/>
-            </a:avLst>
+            <a:avLst/>
           </a:prstGeom>
           <a:solidFill>
             <a:srgbClr val="4ADE80"/>
@@ -3084,6 +2855,13 @@
             <a:prstDash val="solid"/>
           </a:ln>
         </p:spPr>
+        <p:txBody>
+          <a:bodyPr/>
+          <a:lstStyle/>
+          <a:p>
+            <a:endParaRPr lang="es-MX"/>
+          </a:p>
+        </p:txBody>
       </p:sp>
       <p:sp>
         <p:nvSpPr>
@@ -3106,7 +2884,7 @@
           <a:bodyPr wrap="square" rtlCol="0" anchor="ctr"/>
           <a:lstStyle/>
           <a:p>
-            <a:pPr algn="ctr" indent="0" marL="0">
+            <a:pPr marL="0" indent="0" algn="ctr">
               <a:buNone/>
             </a:pPr>
             <a:r>
@@ -3147,7 +2925,7 @@
           </a:bodyPr>
           <a:lstStyle/>
           <a:p>
-            <a:pPr indent="0" marL="0">
+            <a:pPr marL="0" indent="0">
               <a:buNone/>
             </a:pPr>
             <a:r>
@@ -3187,6 +2965,13 @@
             <a:prstDash val="solid"/>
           </a:ln>
         </p:spPr>
+        <p:txBody>
+          <a:bodyPr/>
+          <a:lstStyle/>
+          <a:p>
+            <a:endParaRPr lang="es-MX"/>
+          </a:p>
+        </p:txBody>
       </p:sp>
       <p:sp>
         <p:nvSpPr>
@@ -3209,7 +2994,7 @@
           <a:bodyPr wrap="square" rtlCol="0" anchor="t"/>
           <a:lstStyle/>
           <a:p>
-            <a:pPr indent="0" marL="0">
+            <a:pPr marL="0" indent="0">
               <a:buNone/>
             </a:pPr>
             <a:r>
@@ -3248,7 +3033,7 @@
           <a:bodyPr wrap="square" rtlCol="0" anchor="t"/>
           <a:lstStyle/>
           <a:p>
-            <a:pPr indent="0" marL="0">
+            <a:pPr marL="0" indent="0">
               <a:buNone/>
             </a:pPr>
             <a:r>
@@ -3287,7 +3072,7 @@
           <a:bodyPr wrap="square" rtlCol="0" anchor="t"/>
           <a:lstStyle/>
           <a:p>
-            <a:pPr indent="0" marL="0">
+            <a:pPr marL="0" indent="0">
               <a:buNone/>
             </a:pPr>
             <a:r>
@@ -3326,7 +3111,7 @@
           <a:bodyPr wrap="square" rtlCol="0" anchor="t"/>
           <a:lstStyle/>
           <a:p>
-            <a:pPr indent="0" marL="0">
+            <a:pPr marL="0" indent="0">
               <a:buNone/>
             </a:pPr>
             <a:r>
@@ -3360,6 +3145,7 @@
         <a:solidFill>
           <a:srgbClr val="141929"/>
         </a:solidFill>
+        <a:effectLst/>
       </p:bgPr>
     </p:bg>
     <p:spTree>
@@ -3400,17 +3186,24 @@
             <a:prstDash val="solid"/>
           </a:ln>
         </p:spPr>
+        <p:txBody>
+          <a:bodyPr/>
+          <a:lstStyle/>
+          <a:p>
+            <a:endParaRPr lang="es-MX"/>
+          </a:p>
+        </p:txBody>
       </p:sp>
       <p:pic>
         <p:nvPicPr>
-          <p:cNvPr id="3" name="Image 0" descr="C:\Users\JoseRamonEstradaRend\AppData\Roaming\Claude\local-agent-mode-sessions\skills-plugin\d7d799c7-c68d-4735-9f18-5020fbbe8e77\246afd61-2015-4905-b7d3-2bf63e539570\skills\pptx\screenshots\11_puestos.jpg">    </p:cNvPr>
+          <p:cNvPr id="3" name="Image 0" descr="C:\Users\JoseRamonEstradaRend\AppData\Roaming\Claude\local-agent-mode-sessions\skills-plugin\d7d799c7-c68d-4735-9f18-5020fbbe8e77\246afd61-2015-4905-b7d3-2bf63e539570\skills\pptx\screenshots\11_puestos.jpg"/>
           <p:cNvPicPr>
             <a:picLocks noChangeAspect="1"/>
           </p:cNvPicPr>
           <p:nvPr/>
         </p:nvPicPr>
         <p:blipFill>
-          <a:blip r:embed="rId1"/>
+          <a:blip r:embed="rId3"/>
           <a:stretch>
             <a:fillRect/>
           </a:stretch>
@@ -3424,7 +3217,7 @@
             <a:avLst/>
           </a:prstGeom>
           <a:effectLst>
-            <a:outerShdw sx="100000" sy="100000" kx="0" ky="0" algn="bl" rotWithShape="0" blurRad="152400" dist="50800" dir="2700000">
+            <a:outerShdw blurRad="152400" dist="50800" dir="2700000" algn="bl" rotWithShape="0">
               <a:srgbClr val="000000">
                 <a:alpha val="55000"/>
               </a:srgbClr>
@@ -3444,9 +3237,7 @@
             <a:ext cx="384048" cy="256032"/>
           </a:xfrm>
           <a:prstGeom prst="rect">
-            <a:avLst>
-              <a:gd name="adj" fmla="val 14286"/>
-            </a:avLst>
+            <a:avLst/>
           </a:prstGeom>
           <a:solidFill>
             <a:srgbClr val="4ADE80"/>
@@ -3458,6 +3249,13 @@
             <a:prstDash val="solid"/>
           </a:ln>
         </p:spPr>
+        <p:txBody>
+          <a:bodyPr/>
+          <a:lstStyle/>
+          <a:p>
+            <a:endParaRPr lang="es-MX"/>
+          </a:p>
+        </p:txBody>
       </p:sp>
       <p:sp>
         <p:nvSpPr>
@@ -3480,7 +3278,7 @@
           <a:bodyPr wrap="square" rtlCol="0" anchor="ctr"/>
           <a:lstStyle/>
           <a:p>
-            <a:pPr algn="ctr" indent="0" marL="0">
+            <a:pPr marL="0" indent="0" algn="ctr">
               <a:buNone/>
             </a:pPr>
             <a:r>
@@ -3521,7 +3319,7 @@
           </a:bodyPr>
           <a:lstStyle/>
           <a:p>
-            <a:pPr indent="0" marL="0">
+            <a:pPr marL="0" indent="0">
               <a:buNone/>
             </a:pPr>
             <a:r>
@@ -3561,6 +3359,13 @@
             <a:prstDash val="solid"/>
           </a:ln>
         </p:spPr>
+        <p:txBody>
+          <a:bodyPr/>
+          <a:lstStyle/>
+          <a:p>
+            <a:endParaRPr lang="es-MX"/>
+          </a:p>
+        </p:txBody>
       </p:sp>
       <p:sp>
         <p:nvSpPr>
@@ -3583,7 +3388,7 @@
           <a:bodyPr wrap="square" rtlCol="0" anchor="t"/>
           <a:lstStyle/>
           <a:p>
-            <a:pPr indent="0" marL="0">
+            <a:pPr marL="0" indent="0">
               <a:buNone/>
             </a:pPr>
             <a:r>
@@ -3622,7 +3427,7 @@
           <a:bodyPr wrap="square" rtlCol="0" anchor="t"/>
           <a:lstStyle/>
           <a:p>
-            <a:pPr indent="0" marL="0">
+            <a:pPr marL="0" indent="0">
               <a:buNone/>
             </a:pPr>
             <a:r>
@@ -3661,7 +3466,7 @@
           <a:bodyPr wrap="square" rtlCol="0" anchor="t"/>
           <a:lstStyle/>
           <a:p>
-            <a:pPr indent="0" marL="0">
+            <a:pPr marL="0" indent="0">
               <a:buNone/>
             </a:pPr>
             <a:r>
@@ -3700,7 +3505,7 @@
           <a:bodyPr wrap="square" rtlCol="0" anchor="t"/>
           <a:lstStyle/>
           <a:p>
-            <a:pPr indent="0" marL="0">
+            <a:pPr marL="0" indent="0">
               <a:buNone/>
             </a:pPr>
             <a:r>
@@ -3734,6 +3539,7 @@
         <a:solidFill>
           <a:srgbClr val="141929"/>
         </a:solidFill>
+        <a:effectLst/>
       </p:bgPr>
     </p:bg>
     <p:spTree>
@@ -3774,17 +3580,24 @@
             <a:prstDash val="solid"/>
           </a:ln>
         </p:spPr>
+        <p:txBody>
+          <a:bodyPr/>
+          <a:lstStyle/>
+          <a:p>
+            <a:endParaRPr lang="es-MX"/>
+          </a:p>
+        </p:txBody>
       </p:sp>
       <p:pic>
         <p:nvPicPr>
-          <p:cNvPr id="3" name="Image 0" descr="C:\Users\JoseRamonEstradaRend\AppData\Roaming\Claude\local-agent-mode-sessions\skills-plugin\d7d799c7-c68d-4735-9f18-5020fbbe8e77\246afd61-2015-4905-b7d3-2bf63e539570\skills\pptx\screenshots\13_empresa.jpg">    </p:cNvPr>
+          <p:cNvPr id="3" name="Image 0" descr="C:\Users\JoseRamonEstradaRend\AppData\Roaming\Claude\local-agent-mode-sessions\skills-plugin\d7d799c7-c68d-4735-9f18-5020fbbe8e77\246afd61-2015-4905-b7d3-2bf63e539570\skills\pptx\screenshots\13_empresa.jpg"/>
           <p:cNvPicPr>
             <a:picLocks noChangeAspect="1"/>
           </p:cNvPicPr>
           <p:nvPr/>
         </p:nvPicPr>
         <p:blipFill>
-          <a:blip r:embed="rId1"/>
+          <a:blip r:embed="rId3"/>
           <a:stretch>
             <a:fillRect/>
           </a:stretch>
@@ -3798,7 +3611,7 @@
             <a:avLst/>
           </a:prstGeom>
           <a:effectLst>
-            <a:outerShdw sx="100000" sy="100000" kx="0" ky="0" algn="bl" rotWithShape="0" blurRad="152400" dist="50800" dir="2700000">
+            <a:outerShdw blurRad="152400" dist="50800" dir="2700000" algn="bl" rotWithShape="0">
               <a:srgbClr val="000000">
                 <a:alpha val="55000"/>
               </a:srgbClr>
@@ -3818,9 +3631,7 @@
             <a:ext cx="384048" cy="256032"/>
           </a:xfrm>
           <a:prstGeom prst="rect">
-            <a:avLst>
-              <a:gd name="adj" fmla="val 14286"/>
-            </a:avLst>
+            <a:avLst/>
           </a:prstGeom>
           <a:solidFill>
             <a:srgbClr val="4ADE80"/>
@@ -3832,6 +3643,13 @@
             <a:prstDash val="solid"/>
           </a:ln>
         </p:spPr>
+        <p:txBody>
+          <a:bodyPr/>
+          <a:lstStyle/>
+          <a:p>
+            <a:endParaRPr lang="es-MX"/>
+          </a:p>
+        </p:txBody>
       </p:sp>
       <p:sp>
         <p:nvSpPr>
@@ -3854,7 +3672,7 @@
           <a:bodyPr wrap="square" rtlCol="0" anchor="ctr"/>
           <a:lstStyle/>
           <a:p>
-            <a:pPr algn="ctr" indent="0" marL="0">
+            <a:pPr marL="0" indent="0" algn="ctr">
               <a:buNone/>
             </a:pPr>
             <a:r>
@@ -3895,7 +3713,7 @@
           </a:bodyPr>
           <a:lstStyle/>
           <a:p>
-            <a:pPr indent="0" marL="0">
+            <a:pPr marL="0" indent="0">
               <a:buNone/>
             </a:pPr>
             <a:r>
@@ -3935,6 +3753,13 @@
             <a:prstDash val="solid"/>
           </a:ln>
         </p:spPr>
+        <p:txBody>
+          <a:bodyPr/>
+          <a:lstStyle/>
+          <a:p>
+            <a:endParaRPr lang="es-MX"/>
+          </a:p>
+        </p:txBody>
       </p:sp>
       <p:sp>
         <p:nvSpPr>
@@ -3957,7 +3782,7 @@
           <a:bodyPr wrap="square" rtlCol="0" anchor="t"/>
           <a:lstStyle/>
           <a:p>
-            <a:pPr indent="0" marL="0">
+            <a:pPr marL="0" indent="0">
               <a:buNone/>
             </a:pPr>
             <a:r>
@@ -3996,7 +3821,7 @@
           <a:bodyPr wrap="square" rtlCol="0" anchor="t"/>
           <a:lstStyle/>
           <a:p>
-            <a:pPr indent="0" marL="0">
+            <a:pPr marL="0" indent="0">
               <a:buNone/>
             </a:pPr>
             <a:r>
@@ -4035,7 +3860,7 @@
           <a:bodyPr wrap="square" rtlCol="0" anchor="t"/>
           <a:lstStyle/>
           <a:p>
-            <a:pPr indent="0" marL="0">
+            <a:pPr marL="0" indent="0">
               <a:buNone/>
             </a:pPr>
             <a:r>
@@ -4074,7 +3899,7 @@
           <a:bodyPr wrap="square" rtlCol="0" anchor="t"/>
           <a:lstStyle/>
           <a:p>
-            <a:pPr indent="0" marL="0">
+            <a:pPr marL="0" indent="0">
               <a:buNone/>
             </a:pPr>
             <a:r>
@@ -4108,6 +3933,7 @@
         <a:solidFill>
           <a:srgbClr val="141929"/>
         </a:solidFill>
+        <a:effectLst/>
       </p:bgPr>
     </p:bg>
     <p:spTree>
@@ -4148,17 +3974,24 @@
             <a:prstDash val="solid"/>
           </a:ln>
         </p:spPr>
+        <p:txBody>
+          <a:bodyPr/>
+          <a:lstStyle/>
+          <a:p>
+            <a:endParaRPr lang="es-MX"/>
+          </a:p>
+        </p:txBody>
       </p:sp>
       <p:pic>
         <p:nvPicPr>
-          <p:cNvPr id="3" name="Image 0" descr="C:\Users\JoseRamonEstradaRend\AppData\Roaming\Claude\local-agent-mode-sessions\skills-plugin\d7d799c7-c68d-4735-9f18-5020fbbe8e77\246afd61-2015-4905-b7d3-2bf63e539570\skills\pptx\screenshots\14_anuncios.jpg">    </p:cNvPr>
+          <p:cNvPr id="3" name="Image 0" descr="C:\Users\JoseRamonEstradaRend\AppData\Roaming\Claude\local-agent-mode-sessions\skills-plugin\d7d799c7-c68d-4735-9f18-5020fbbe8e77\246afd61-2015-4905-b7d3-2bf63e539570\skills\pptx\screenshots\14_anuncios.jpg"/>
           <p:cNvPicPr>
             <a:picLocks noChangeAspect="1"/>
           </p:cNvPicPr>
           <p:nvPr/>
         </p:nvPicPr>
         <p:blipFill>
-          <a:blip r:embed="rId1"/>
+          <a:blip r:embed="rId3"/>
           <a:stretch>
             <a:fillRect/>
           </a:stretch>
@@ -4172,7 +4005,7 @@
             <a:avLst/>
           </a:prstGeom>
           <a:effectLst>
-            <a:outerShdw sx="100000" sy="100000" kx="0" ky="0" algn="bl" rotWithShape="0" blurRad="152400" dist="50800" dir="2700000">
+            <a:outerShdw blurRad="152400" dist="50800" dir="2700000" algn="bl" rotWithShape="0">
               <a:srgbClr val="000000">
                 <a:alpha val="55000"/>
               </a:srgbClr>
@@ -4192,9 +4025,7 @@
             <a:ext cx="384048" cy="256032"/>
           </a:xfrm>
           <a:prstGeom prst="rect">
-            <a:avLst>
-              <a:gd name="adj" fmla="val 14286"/>
-            </a:avLst>
+            <a:avLst/>
           </a:prstGeom>
           <a:solidFill>
             <a:srgbClr val="4ADE80"/>
@@ -4206,6 +4037,13 @@
             <a:prstDash val="solid"/>
           </a:ln>
         </p:spPr>
+        <p:txBody>
+          <a:bodyPr/>
+          <a:lstStyle/>
+          <a:p>
+            <a:endParaRPr lang="es-MX"/>
+          </a:p>
+        </p:txBody>
       </p:sp>
       <p:sp>
         <p:nvSpPr>
@@ -4228,7 +4066,7 @@
           <a:bodyPr wrap="square" rtlCol="0" anchor="ctr"/>
           <a:lstStyle/>
           <a:p>
-            <a:pPr algn="ctr" indent="0" marL="0">
+            <a:pPr marL="0" indent="0" algn="ctr">
               <a:buNone/>
             </a:pPr>
             <a:r>
@@ -4269,7 +4107,7 @@
           </a:bodyPr>
           <a:lstStyle/>
           <a:p>
-            <a:pPr indent="0" marL="0">
+            <a:pPr marL="0" indent="0">
               <a:buNone/>
             </a:pPr>
             <a:r>
@@ -4309,6 +4147,13 @@
             <a:prstDash val="solid"/>
           </a:ln>
         </p:spPr>
+        <p:txBody>
+          <a:bodyPr/>
+          <a:lstStyle/>
+          <a:p>
+            <a:endParaRPr lang="es-MX"/>
+          </a:p>
+        </p:txBody>
       </p:sp>
       <p:sp>
         <p:nvSpPr>
@@ -4331,7 +4176,7 @@
           <a:bodyPr wrap="square" rtlCol="0" anchor="t"/>
           <a:lstStyle/>
           <a:p>
-            <a:pPr indent="0" marL="0">
+            <a:pPr marL="0" indent="0">
               <a:buNone/>
             </a:pPr>
             <a:r>
@@ -4370,7 +4215,7 @@
           <a:bodyPr wrap="square" rtlCol="0" anchor="t"/>
           <a:lstStyle/>
           <a:p>
-            <a:pPr indent="0" marL="0">
+            <a:pPr marL="0" indent="0">
               <a:buNone/>
             </a:pPr>
             <a:r>
@@ -4409,7 +4254,7 @@
           <a:bodyPr wrap="square" rtlCol="0" anchor="t"/>
           <a:lstStyle/>
           <a:p>
-            <a:pPr indent="0" marL="0">
+            <a:pPr marL="0" indent="0">
               <a:buNone/>
             </a:pPr>
             <a:r>
@@ -4448,7 +4293,7 @@
           <a:bodyPr wrap="square" rtlCol="0" anchor="t"/>
           <a:lstStyle/>
           <a:p>
-            <a:pPr indent="0" marL="0">
+            <a:pPr marL="0" indent="0">
               <a:buNone/>
             </a:pPr>
             <a:r>
@@ -4482,6 +4327,7 @@
         <a:solidFill>
           <a:srgbClr val="0B0F1A"/>
         </a:solidFill>
+        <a:effectLst/>
       </p:bgPr>
     </p:bg>
     <p:spTree>
@@ -4519,7 +4365,7 @@
           <a:bodyPr wrap="square" rtlCol="0" anchor="ctr"/>
           <a:lstStyle/>
           <a:p>
-            <a:pPr indent="0" marL="0">
+            <a:pPr marL="0" indent="0">
               <a:buNone/>
             </a:pPr>
             <a:r>
@@ -4533,9 +4379,6 @@
               </a:rPr>
               <a:t>KronOS</a:t>
             </a:r>
-            <a:pPr indent="0" marL="0">
-              <a:buNone/>
-            </a:pPr>
             <a:r>
               <a:rPr lang="en-US" sz="3200" dirty="0">
                 <a:solidFill>
@@ -4547,9 +4390,6 @@
               </a:rPr>
               <a:t>  vs  </a:t>
             </a:r>
-            <a:pPr indent="0" marL="0">
-              <a:buNone/>
-            </a:pPr>
             <a:r>
               <a:rPr lang="en-US" sz="3200" b="1" dirty="0">
                 <a:solidFill>
@@ -4586,7 +4426,7 @@
           <a:bodyPr wrap="square" rtlCol="0" anchor="ctr"/>
           <a:lstStyle/>
           <a:p>
-            <a:pPr indent="0" marL="0">
+            <a:pPr marL="0" indent="0">
               <a:buNone/>
             </a:pPr>
             <a:r>
@@ -4627,9 +4467,27 @@
             <a:tbl>
               <a:tblPr/>
               <a:tblGrid>
-                <a:gridCol w="2011680"/>
-                <a:gridCol w="3200400"/>
-                <a:gridCol w="3200400"/>
+                <a:gridCol w="2011680">
+                  <a:extLst>
+                    <a:ext uri="{9D8B030D-6E8A-4147-A177-3AD203B41FA5}">
+                      <a16:colId xmlns:a16="http://schemas.microsoft.com/office/drawing/2014/main" val="20000"/>
+                    </a:ext>
+                  </a:extLst>
+                </a:gridCol>
+                <a:gridCol w="3200400">
+                  <a:extLst>
+                    <a:ext uri="{9D8B030D-6E8A-4147-A177-3AD203B41FA5}">
+                      <a16:colId xmlns:a16="http://schemas.microsoft.com/office/drawing/2014/main" val="20001"/>
+                    </a:ext>
+                  </a:extLst>
+                </a:gridCol>
+                <a:gridCol w="3200400">
+                  <a:extLst>
+                    <a:ext uri="{9D8B030D-6E8A-4147-A177-3AD203B41FA5}">
+                      <a16:colId xmlns:a16="http://schemas.microsoft.com/office/drawing/2014/main" val="20002"/>
+                    </a:ext>
+                  </a:extLst>
+                </a:gridCol>
               </a:tblGrid>
               <a:tr h="411480">
                 <a:tc>
@@ -4637,7 +4495,7 @@
                     <a:bodyPr/>
                     <a:lstStyle/>
                     <a:p>
-                      <a:pPr indent="0" marL="0">
+                      <a:pPr marL="0" indent="0">
                         <a:buNone/>
                       </a:pPr>
                       <a:r>
@@ -4658,7 +4516,7 @@
                       </a:endParaRPr>
                     </a:p>
                   </a:txBody>
-                  <a:tcPr marL="91440" marR="91440" marT="45720" marB="45720">
+                  <a:tcPr>
                     <a:lnL w="12700" cap="flat" cmpd="sng" algn="ctr">
                       <a:solidFill>
                         <a:srgbClr val="1E2A45"/>
@@ -4705,7 +4563,7 @@
                     <a:bodyPr/>
                     <a:lstStyle/>
                     <a:p>
-                      <a:pPr indent="0" marL="0">
+                      <a:pPr marL="0" indent="0">
                         <a:buNone/>
                       </a:pPr>
                       <a:r>
@@ -4726,7 +4584,7 @@
                       </a:endParaRPr>
                     </a:p>
                   </a:txBody>
-                  <a:tcPr marL="91440" marR="91440" marT="45720" marB="45720">
+                  <a:tcPr>
                     <a:lnL w="12700" cap="flat" cmpd="sng" algn="ctr">
                       <a:solidFill>
                         <a:srgbClr val="1E2A45"/>
@@ -4773,7 +4631,7 @@
                     <a:bodyPr/>
                     <a:lstStyle/>
                     <a:p>
-                      <a:pPr indent="0" marL="0">
+                      <a:pPr marL="0" indent="0">
                         <a:buNone/>
                       </a:pPr>
                       <a:r>
@@ -4794,7 +4652,7 @@
                       </a:endParaRPr>
                     </a:p>
                   </a:txBody>
-                  <a:tcPr marL="91440" marR="91440" marT="45720" marB="45720">
+                  <a:tcPr>
                     <a:lnL w="12700" cap="flat" cmpd="sng" algn="ctr">
                       <a:solidFill>
                         <a:srgbClr val="1E2A45"/>
@@ -4836,6 +4694,11 @@
                     </a:solidFill>
                   </a:tcPr>
                 </a:tc>
+                <a:extLst>
+                  <a:ext uri="{0D108BD9-81ED-4DB2-BD59-A6C34878D82A}">
+                    <a16:rowId xmlns:a16="http://schemas.microsoft.com/office/drawing/2014/main" val="10000"/>
+                  </a:ext>
+                </a:extLst>
               </a:tr>
               <a:tr h="411480">
                 <a:tc>
@@ -4843,7 +4706,7 @@
                     <a:bodyPr/>
                     <a:lstStyle/>
                     <a:p>
-                      <a:pPr indent="0" marL="0">
+                      <a:pPr marL="0" indent="0">
                         <a:buNone/>
                       </a:pPr>
                       <a:r>
@@ -4864,7 +4727,7 @@
                       </a:endParaRPr>
                     </a:p>
                   </a:txBody>
-                  <a:tcPr marL="91440" marR="91440" marT="45720" marB="45720">
+                  <a:tcPr>
                     <a:lnL w="12700" cap="flat" cmpd="sng" algn="ctr">
                       <a:solidFill>
                         <a:srgbClr val="1E2A45"/>
@@ -4911,7 +4774,7 @@
                     <a:bodyPr/>
                     <a:lstStyle/>
                     <a:p>
-                      <a:pPr indent="0" marL="0">
+                      <a:pPr marL="0" indent="0">
                         <a:buNone/>
                       </a:pPr>
                       <a:r>
@@ -4932,7 +4795,7 @@
                       </a:endParaRPr>
                     </a:p>
                   </a:txBody>
-                  <a:tcPr marL="91440" marR="91440" marT="45720" marB="45720">
+                  <a:tcPr>
                     <a:lnL w="12700" cap="flat" cmpd="sng" algn="ctr">
                       <a:solidFill>
                         <a:srgbClr val="1E2A45"/>
@@ -4979,7 +4842,7 @@
                     <a:bodyPr/>
                     <a:lstStyle/>
                     <a:p>
-                      <a:pPr indent="0" marL="0">
+                      <a:pPr marL="0" indent="0">
                         <a:buNone/>
                       </a:pPr>
                       <a:r>
@@ -5000,7 +4863,7 @@
                       </a:endParaRPr>
                     </a:p>
                   </a:txBody>
-                  <a:tcPr marL="91440" marR="91440" marT="45720" marB="45720">
+                  <a:tcPr>
                     <a:lnL w="12700" cap="flat" cmpd="sng" algn="ctr">
                       <a:solidFill>
                         <a:srgbClr val="1E2A45"/>
@@ -5042,6 +4905,11 @@
                     </a:solidFill>
                   </a:tcPr>
                 </a:tc>
+                <a:extLst>
+                  <a:ext uri="{0D108BD9-81ED-4DB2-BD59-A6C34878D82A}">
+                    <a16:rowId xmlns:a16="http://schemas.microsoft.com/office/drawing/2014/main" val="10001"/>
+                  </a:ext>
+                </a:extLst>
               </a:tr>
               <a:tr h="411480">
                 <a:tc>
@@ -5049,7 +4917,7 @@
                     <a:bodyPr/>
                     <a:lstStyle/>
                     <a:p>
-                      <a:pPr indent="0" marL="0">
+                      <a:pPr marL="0" indent="0">
                         <a:buNone/>
                       </a:pPr>
                       <a:r>
@@ -5070,7 +4938,7 @@
                       </a:endParaRPr>
                     </a:p>
                   </a:txBody>
-                  <a:tcPr marL="91440" marR="91440" marT="45720" marB="45720">
+                  <a:tcPr>
                     <a:lnL w="12700" cap="flat" cmpd="sng" algn="ctr">
                       <a:solidFill>
                         <a:srgbClr val="1E2A45"/>
@@ -5117,7 +4985,7 @@
                     <a:bodyPr/>
                     <a:lstStyle/>
                     <a:p>
-                      <a:pPr indent="0" marL="0">
+                      <a:pPr marL="0" indent="0">
                         <a:buNone/>
                       </a:pPr>
                       <a:r>
@@ -5138,7 +5006,7 @@
                       </a:endParaRPr>
                     </a:p>
                   </a:txBody>
-                  <a:tcPr marL="91440" marR="91440" marT="45720" marB="45720">
+                  <a:tcPr>
                     <a:lnL w="12700" cap="flat" cmpd="sng" algn="ctr">
                       <a:solidFill>
                         <a:srgbClr val="1E2A45"/>
@@ -5185,7 +5053,7 @@
                     <a:bodyPr/>
                     <a:lstStyle/>
                     <a:p>
-                      <a:pPr indent="0" marL="0">
+                      <a:pPr marL="0" indent="0">
                         <a:buNone/>
                       </a:pPr>
                       <a:r>
@@ -5206,7 +5074,7 @@
                       </a:endParaRPr>
                     </a:p>
                   </a:txBody>
-                  <a:tcPr marL="91440" marR="91440" marT="45720" marB="45720">
+                  <a:tcPr>
                     <a:lnL w="12700" cap="flat" cmpd="sng" algn="ctr">
                       <a:solidFill>
                         <a:srgbClr val="1E2A45"/>
@@ -5248,6 +5116,11 @@
                     </a:solidFill>
                   </a:tcPr>
                 </a:tc>
+                <a:extLst>
+                  <a:ext uri="{0D108BD9-81ED-4DB2-BD59-A6C34878D82A}">
+                    <a16:rowId xmlns:a16="http://schemas.microsoft.com/office/drawing/2014/main" val="10002"/>
+                  </a:ext>
+                </a:extLst>
               </a:tr>
               <a:tr h="411480">
                 <a:tc>
@@ -5255,7 +5128,7 @@
                     <a:bodyPr/>
                     <a:lstStyle/>
                     <a:p>
-                      <a:pPr indent="0" marL="0">
+                      <a:pPr marL="0" indent="0">
                         <a:buNone/>
                       </a:pPr>
                       <a:r>
@@ -5276,7 +5149,7 @@
                       </a:endParaRPr>
                     </a:p>
                   </a:txBody>
-                  <a:tcPr marL="91440" marR="91440" marT="45720" marB="45720">
+                  <a:tcPr>
                     <a:lnL w="12700" cap="flat" cmpd="sng" algn="ctr">
                       <a:solidFill>
                         <a:srgbClr val="1E2A45"/>
@@ -5323,7 +5196,7 @@
                     <a:bodyPr/>
                     <a:lstStyle/>
                     <a:p>
-                      <a:pPr indent="0" marL="0">
+                      <a:pPr marL="0" indent="0">
                         <a:buNone/>
                       </a:pPr>
                       <a:r>
@@ -5344,7 +5217,7 @@
                       </a:endParaRPr>
                     </a:p>
                   </a:txBody>
-                  <a:tcPr marL="91440" marR="91440" marT="45720" marB="45720">
+                  <a:tcPr>
                     <a:lnL w="12700" cap="flat" cmpd="sng" algn="ctr">
                       <a:solidFill>
                         <a:srgbClr val="1E2A45"/>
@@ -5391,7 +5264,7 @@
                     <a:bodyPr/>
                     <a:lstStyle/>
                     <a:p>
-                      <a:pPr indent="0" marL="0">
+                      <a:pPr marL="0" indent="0">
                         <a:buNone/>
                       </a:pPr>
                       <a:r>
@@ -5412,7 +5285,7 @@
                       </a:endParaRPr>
                     </a:p>
                   </a:txBody>
-                  <a:tcPr marL="91440" marR="91440" marT="45720" marB="45720">
+                  <a:tcPr>
                     <a:lnL w="12700" cap="flat" cmpd="sng" algn="ctr">
                       <a:solidFill>
                         <a:srgbClr val="1E2A45"/>
@@ -5454,6 +5327,11 @@
                     </a:solidFill>
                   </a:tcPr>
                 </a:tc>
+                <a:extLst>
+                  <a:ext uri="{0D108BD9-81ED-4DB2-BD59-A6C34878D82A}">
+                    <a16:rowId xmlns:a16="http://schemas.microsoft.com/office/drawing/2014/main" val="10003"/>
+                  </a:ext>
+                </a:extLst>
               </a:tr>
               <a:tr h="411480">
                 <a:tc>
@@ -5461,7 +5339,7 @@
                     <a:bodyPr/>
                     <a:lstStyle/>
                     <a:p>
-                      <a:pPr indent="0" marL="0">
+                      <a:pPr marL="0" indent="0">
                         <a:buNone/>
                       </a:pPr>
                       <a:r>
@@ -5482,7 +5360,7 @@
                       </a:endParaRPr>
                     </a:p>
                   </a:txBody>
-                  <a:tcPr marL="91440" marR="91440" marT="45720" marB="45720">
+                  <a:tcPr>
                     <a:lnL w="12700" cap="flat" cmpd="sng" algn="ctr">
                       <a:solidFill>
                         <a:srgbClr val="1E2A45"/>
@@ -5529,7 +5407,7 @@
                     <a:bodyPr/>
                     <a:lstStyle/>
                     <a:p>
-                      <a:pPr indent="0" marL="0">
+                      <a:pPr marL="0" indent="0">
                         <a:buNone/>
                       </a:pPr>
                       <a:r>
@@ -5550,7 +5428,7 @@
                       </a:endParaRPr>
                     </a:p>
                   </a:txBody>
-                  <a:tcPr marL="91440" marR="91440" marT="45720" marB="45720">
+                  <a:tcPr>
                     <a:lnL w="12700" cap="flat" cmpd="sng" algn="ctr">
                       <a:solidFill>
                         <a:srgbClr val="1E2A45"/>
@@ -5597,7 +5475,7 @@
                     <a:bodyPr/>
                     <a:lstStyle/>
                     <a:p>
-                      <a:pPr indent="0" marL="0">
+                      <a:pPr marL="0" indent="0">
                         <a:buNone/>
                       </a:pPr>
                       <a:r>
@@ -5618,7 +5496,7 @@
                       </a:endParaRPr>
                     </a:p>
                   </a:txBody>
-                  <a:tcPr marL="91440" marR="91440" marT="45720" marB="45720">
+                  <a:tcPr>
                     <a:lnL w="12700" cap="flat" cmpd="sng" algn="ctr">
                       <a:solidFill>
                         <a:srgbClr val="1E2A45"/>
@@ -5660,6 +5538,11 @@
                     </a:solidFill>
                   </a:tcPr>
                 </a:tc>
+                <a:extLst>
+                  <a:ext uri="{0D108BD9-81ED-4DB2-BD59-A6C34878D82A}">
+                    <a16:rowId xmlns:a16="http://schemas.microsoft.com/office/drawing/2014/main" val="10004"/>
+                  </a:ext>
+                </a:extLst>
               </a:tr>
               <a:tr h="411480">
                 <a:tc>
@@ -5667,7 +5550,7 @@
                     <a:bodyPr/>
                     <a:lstStyle/>
                     <a:p>
-                      <a:pPr indent="0" marL="0">
+                      <a:pPr marL="0" indent="0">
                         <a:buNone/>
                       </a:pPr>
                       <a:r>
@@ -5688,7 +5571,7 @@
                       </a:endParaRPr>
                     </a:p>
                   </a:txBody>
-                  <a:tcPr marL="91440" marR="91440" marT="45720" marB="45720">
+                  <a:tcPr>
                     <a:lnL w="12700" cap="flat" cmpd="sng" algn="ctr">
                       <a:solidFill>
                         <a:srgbClr val="1E2A45"/>
@@ -5735,7 +5618,7 @@
                     <a:bodyPr/>
                     <a:lstStyle/>
                     <a:p>
-                      <a:pPr indent="0" marL="0">
+                      <a:pPr marL="0" indent="0">
                         <a:buNone/>
                       </a:pPr>
                       <a:r>
@@ -5756,7 +5639,7 @@
                       </a:endParaRPr>
                     </a:p>
                   </a:txBody>
-                  <a:tcPr marL="91440" marR="91440" marT="45720" marB="45720">
+                  <a:tcPr>
                     <a:lnL w="12700" cap="flat" cmpd="sng" algn="ctr">
                       <a:solidFill>
                         <a:srgbClr val="1E2A45"/>
@@ -5803,7 +5686,7 @@
                     <a:bodyPr/>
                     <a:lstStyle/>
                     <a:p>
-                      <a:pPr indent="0" marL="0">
+                      <a:pPr marL="0" indent="0">
                         <a:buNone/>
                       </a:pPr>
                       <a:r>
@@ -5824,7 +5707,7 @@
                       </a:endParaRPr>
                     </a:p>
                   </a:txBody>
-                  <a:tcPr marL="91440" marR="91440" marT="45720" marB="45720">
+                  <a:tcPr>
                     <a:lnL w="12700" cap="flat" cmpd="sng" algn="ctr">
                       <a:solidFill>
                         <a:srgbClr val="1E2A45"/>
@@ -5866,6 +5749,11 @@
                     </a:solidFill>
                   </a:tcPr>
                 </a:tc>
+                <a:extLst>
+                  <a:ext uri="{0D108BD9-81ED-4DB2-BD59-A6C34878D82A}">
+                    <a16:rowId xmlns:a16="http://schemas.microsoft.com/office/drawing/2014/main" val="10005"/>
+                  </a:ext>
+                </a:extLst>
               </a:tr>
               <a:tr h="411480">
                 <a:tc>
@@ -5873,7 +5761,7 @@
                     <a:bodyPr/>
                     <a:lstStyle/>
                     <a:p>
-                      <a:pPr indent="0" marL="0">
+                      <a:pPr marL="0" indent="0">
                         <a:buNone/>
                       </a:pPr>
                       <a:r>
@@ -5894,7 +5782,7 @@
                       </a:endParaRPr>
                     </a:p>
                   </a:txBody>
-                  <a:tcPr marL="91440" marR="91440" marT="45720" marB="45720">
+                  <a:tcPr>
                     <a:lnL w="12700" cap="flat" cmpd="sng" algn="ctr">
                       <a:solidFill>
                         <a:srgbClr val="1E2A45"/>
@@ -5941,7 +5829,7 @@
                     <a:bodyPr/>
                     <a:lstStyle/>
                     <a:p>
-                      <a:pPr indent="0" marL="0">
+                      <a:pPr marL="0" indent="0">
                         <a:buNone/>
                       </a:pPr>
                       <a:r>
@@ -5962,7 +5850,7 @@
                       </a:endParaRPr>
                     </a:p>
                   </a:txBody>
-                  <a:tcPr marL="91440" marR="91440" marT="45720" marB="45720">
+                  <a:tcPr>
                     <a:lnL w="12700" cap="flat" cmpd="sng" algn="ctr">
                       <a:solidFill>
                         <a:srgbClr val="1E2A45"/>
@@ -6009,7 +5897,7 @@
                     <a:bodyPr/>
                     <a:lstStyle/>
                     <a:p>
-                      <a:pPr indent="0" marL="0">
+                      <a:pPr marL="0" indent="0">
                         <a:buNone/>
                       </a:pPr>
                       <a:r>
@@ -6030,7 +5918,7 @@
                       </a:endParaRPr>
                     </a:p>
                   </a:txBody>
-                  <a:tcPr marL="91440" marR="91440" marT="45720" marB="45720">
+                  <a:tcPr>
                     <a:lnL w="12700" cap="flat" cmpd="sng" algn="ctr">
                       <a:solidFill>
                         <a:srgbClr val="1E2A45"/>
@@ -6072,6 +5960,11 @@
                     </a:solidFill>
                   </a:tcPr>
                 </a:tc>
+                <a:extLst>
+                  <a:ext uri="{0D108BD9-81ED-4DB2-BD59-A6C34878D82A}">
+                    <a16:rowId xmlns:a16="http://schemas.microsoft.com/office/drawing/2014/main" val="10006"/>
+                  </a:ext>
+                </a:extLst>
               </a:tr>
               <a:tr h="411480">
                 <a:tc>
@@ -6079,7 +5972,7 @@
                     <a:bodyPr/>
                     <a:lstStyle/>
                     <a:p>
-                      <a:pPr indent="0" marL="0">
+                      <a:pPr marL="0" indent="0">
                         <a:buNone/>
                       </a:pPr>
                       <a:r>
@@ -6100,7 +5993,7 @@
                       </a:endParaRPr>
                     </a:p>
                   </a:txBody>
-                  <a:tcPr marL="91440" marR="91440" marT="45720" marB="45720">
+                  <a:tcPr>
                     <a:lnL w="12700" cap="flat" cmpd="sng" algn="ctr">
                       <a:solidFill>
                         <a:srgbClr val="1E2A45"/>
@@ -6147,7 +6040,7 @@
                     <a:bodyPr/>
                     <a:lstStyle/>
                     <a:p>
-                      <a:pPr indent="0" marL="0">
+                      <a:pPr marL="0" indent="0">
                         <a:buNone/>
                       </a:pPr>
                       <a:r>
@@ -6168,7 +6061,7 @@
                       </a:endParaRPr>
                     </a:p>
                   </a:txBody>
-                  <a:tcPr marL="91440" marR="91440" marT="45720" marB="45720">
+                  <a:tcPr>
                     <a:lnL w="12700" cap="flat" cmpd="sng" algn="ctr">
                       <a:solidFill>
                         <a:srgbClr val="1E2A45"/>
@@ -6215,7 +6108,7 @@
                     <a:bodyPr/>
                     <a:lstStyle/>
                     <a:p>
-                      <a:pPr indent="0" marL="0">
+                      <a:pPr marL="0" indent="0">
                         <a:buNone/>
                       </a:pPr>
                       <a:r>
@@ -6236,7 +6129,7 @@
                       </a:endParaRPr>
                     </a:p>
                   </a:txBody>
-                  <a:tcPr marL="91440" marR="91440" marT="45720" marB="45720">
+                  <a:tcPr>
                     <a:lnL w="12700" cap="flat" cmpd="sng" algn="ctr">
                       <a:solidFill>
                         <a:srgbClr val="1E2A45"/>
@@ -6278,6 +6171,11 @@
                     </a:solidFill>
                   </a:tcPr>
                 </a:tc>
+                <a:extLst>
+                  <a:ext uri="{0D108BD9-81ED-4DB2-BD59-A6C34878D82A}">
+                    <a16:rowId xmlns:a16="http://schemas.microsoft.com/office/drawing/2014/main" val="10007"/>
+                  </a:ext>
+                </a:extLst>
               </a:tr>
               <a:tr h="411480">
                 <a:tc>
@@ -6285,7 +6183,7 @@
                     <a:bodyPr/>
                     <a:lstStyle/>
                     <a:p>
-                      <a:pPr indent="0" marL="0">
+                      <a:pPr marL="0" indent="0">
                         <a:buNone/>
                       </a:pPr>
                       <a:r>
@@ -6306,7 +6204,7 @@
                       </a:endParaRPr>
                     </a:p>
                   </a:txBody>
-                  <a:tcPr marL="91440" marR="91440" marT="45720" marB="45720">
+                  <a:tcPr>
                     <a:lnL w="12700" cap="flat" cmpd="sng" algn="ctr">
                       <a:solidFill>
                         <a:srgbClr val="1E2A45"/>
@@ -6353,7 +6251,7 @@
                     <a:bodyPr/>
                     <a:lstStyle/>
                     <a:p>
-                      <a:pPr indent="0" marL="0">
+                      <a:pPr marL="0" indent="0">
                         <a:buNone/>
                       </a:pPr>
                       <a:r>
@@ -6374,7 +6272,7 @@
                       </a:endParaRPr>
                     </a:p>
                   </a:txBody>
-                  <a:tcPr marL="91440" marR="91440" marT="45720" marB="45720">
+                  <a:tcPr>
                     <a:lnL w="12700" cap="flat" cmpd="sng" algn="ctr">
                       <a:solidFill>
                         <a:srgbClr val="1E2A45"/>
@@ -6421,7 +6319,7 @@
                     <a:bodyPr/>
                     <a:lstStyle/>
                     <a:p>
-                      <a:pPr indent="0" marL="0">
+                      <a:pPr marL="0" indent="0">
                         <a:buNone/>
                       </a:pPr>
                       <a:r>
@@ -6442,7 +6340,7 @@
                       </a:endParaRPr>
                     </a:p>
                   </a:txBody>
-                  <a:tcPr marL="91440" marR="91440" marT="45720" marB="45720">
+                  <a:tcPr>
                     <a:lnL w="12700" cap="flat" cmpd="sng" algn="ctr">
                       <a:solidFill>
                         <a:srgbClr val="1E2A45"/>
@@ -6484,6 +6382,11 @@
                     </a:solidFill>
                   </a:tcPr>
                 </a:tc>
+                <a:extLst>
+                  <a:ext uri="{0D108BD9-81ED-4DB2-BD59-A6C34878D82A}">
+                    <a16:rowId xmlns:a16="http://schemas.microsoft.com/office/drawing/2014/main" val="10008"/>
+                  </a:ext>
+                </a:extLst>
               </a:tr>
             </a:tbl>
           </a:graphicData>
@@ -6505,6 +6408,7 @@
         <a:solidFill>
           <a:srgbClr val="141929"/>
         </a:solidFill>
+        <a:effectLst/>
       </p:bgPr>
     </p:bg>
     <p:spTree>
@@ -6545,6 +6449,13 @@
             <a:prstDash val="solid"/>
           </a:ln>
         </p:spPr>
+        <p:txBody>
+          <a:bodyPr/>
+          <a:lstStyle/>
+          <a:p>
+            <a:endParaRPr lang="es-MX"/>
+          </a:p>
+        </p:txBody>
       </p:sp>
       <p:sp>
         <p:nvSpPr>
@@ -6567,7 +6478,7 @@
           <a:bodyPr wrap="square" rtlCol="0" anchor="ctr"/>
           <a:lstStyle/>
           <a:p>
-            <a:pPr indent="0" marL="0">
+            <a:pPr marL="0" indent="0">
               <a:buNone/>
             </a:pPr>
             <a:r>
@@ -6606,7 +6517,7 @@
           <a:bodyPr wrap="square" rtlCol="0" anchor="ctr"/>
           <a:lstStyle/>
           <a:p>
-            <a:pPr indent="0" marL="0">
+            <a:pPr marL="0" indent="0">
               <a:buNone/>
             </a:pPr>
             <a:r>
@@ -6636,9 +6547,7 @@
             <a:ext cx="2743200" cy="3108960"/>
           </a:xfrm>
           <a:prstGeom prst="rect">
-            <a:avLst>
-              <a:gd name="adj" fmla="val 2667"/>
-            </a:avLst>
+            <a:avLst/>
           </a:prstGeom>
           <a:solidFill>
             <a:srgbClr val="1E2A45"/>
@@ -6650,13 +6559,20 @@
             <a:prstDash val="solid"/>
           </a:ln>
           <a:effectLst>
-            <a:outerShdw sx="100000" sy="100000" kx="0" ky="0" algn="bl" rotWithShape="0" blurRad="101600" dist="38100" dir="2700000">
+            <a:outerShdw blurRad="101600" dist="38100" dir="2700000" algn="bl" rotWithShape="0">
               <a:srgbClr val="000000">
                 <a:alpha val="35000"/>
               </a:srgbClr>
             </a:outerShdw>
           </a:effectLst>
         </p:spPr>
+        <p:txBody>
+          <a:bodyPr/>
+          <a:lstStyle/>
+          <a:p>
+            <a:endParaRPr lang="es-MX"/>
+          </a:p>
+        </p:txBody>
       </p:sp>
       <p:sp>
         <p:nvSpPr>
@@ -6679,7 +6595,7 @@
           <a:bodyPr wrap="square" rtlCol="0" anchor="ctr"/>
           <a:lstStyle/>
           <a:p>
-            <a:pPr indent="0" marL="0">
+            <a:pPr marL="0" indent="0">
               <a:buNone/>
             </a:pPr>
             <a:r>
@@ -6719,6 +6635,13 @@
             <a:prstDash val="solid"/>
           </a:ln>
         </p:spPr>
+        <p:txBody>
+          <a:bodyPr/>
+          <a:lstStyle/>
+          <a:p>
+            <a:endParaRPr lang="es-MX"/>
+          </a:p>
+        </p:txBody>
       </p:sp>
       <p:sp>
         <p:nvSpPr>
@@ -6741,7 +6664,7 @@
           <a:bodyPr wrap="square" rtlCol="0" anchor="ctr"/>
           <a:lstStyle/>
           <a:p>
-            <a:pPr indent="0" marL="0">
+            <a:pPr marL="0" indent="0">
               <a:buNone/>
             </a:pPr>
             <a:r>
@@ -6780,7 +6703,7 @@
           <a:bodyPr wrap="square" rtlCol="0" anchor="ctr"/>
           <a:lstStyle/>
           <a:p>
-            <a:pPr indent="0" marL="0">
+            <a:pPr marL="0" indent="0">
               <a:buNone/>
             </a:pPr>
             <a:r>
@@ -6819,7 +6742,7 @@
           <a:bodyPr wrap="square" rtlCol="0" anchor="ctr"/>
           <a:lstStyle/>
           <a:p>
-            <a:pPr indent="0" marL="0">
+            <a:pPr marL="0" indent="0">
               <a:buNone/>
             </a:pPr>
             <a:r>
@@ -6858,7 +6781,7 @@
           <a:bodyPr wrap="square" rtlCol="0" anchor="ctr"/>
           <a:lstStyle/>
           <a:p>
-            <a:pPr indent="0" marL="0">
+            <a:pPr marL="0" indent="0">
               <a:buNone/>
             </a:pPr>
             <a:r>
@@ -6897,7 +6820,7 @@
           <a:bodyPr wrap="square" rtlCol="0" anchor="ctr"/>
           <a:lstStyle/>
           <a:p>
-            <a:pPr indent="0" marL="0">
+            <a:pPr marL="0" indent="0">
               <a:buNone/>
             </a:pPr>
             <a:r>
@@ -6936,7 +6859,7 @@
           <a:bodyPr wrap="square" rtlCol="0" anchor="ctr"/>
           <a:lstStyle/>
           <a:p>
-            <a:pPr indent="0" marL="0">
+            <a:pPr marL="0" indent="0">
               <a:buNone/>
             </a:pPr>
             <a:r>
@@ -6975,7 +6898,7 @@
           <a:bodyPr wrap="square" rtlCol="0" anchor="ctr"/>
           <a:lstStyle/>
           <a:p>
-            <a:pPr indent="0" marL="0">
+            <a:pPr marL="0" indent="0">
               <a:buNone/>
             </a:pPr>
             <a:r>
@@ -7014,7 +6937,7 @@
           <a:bodyPr wrap="square" rtlCol="0" anchor="ctr"/>
           <a:lstStyle/>
           <a:p>
-            <a:pPr indent="0" marL="0">
+            <a:pPr marL="0" indent="0">
               <a:buNone/>
             </a:pPr>
             <a:r>
@@ -7044,9 +6967,7 @@
             <a:ext cx="2560320" cy="347472"/>
           </a:xfrm>
           <a:prstGeom prst="rect">
-            <a:avLst>
-              <a:gd name="adj" fmla="val 10526"/>
-            </a:avLst>
+            <a:avLst/>
           </a:prstGeom>
           <a:solidFill>
             <a:srgbClr val="0B0F1A"/>
@@ -7058,6 +6979,13 @@
             <a:prstDash val="solid"/>
           </a:ln>
         </p:spPr>
+        <p:txBody>
+          <a:bodyPr/>
+          <a:lstStyle/>
+          <a:p>
+            <a:endParaRPr lang="es-MX"/>
+          </a:p>
+        </p:txBody>
       </p:sp>
       <p:sp>
         <p:nvSpPr>
@@ -7080,7 +7008,7 @@
           <a:bodyPr wrap="square" rtlCol="0" anchor="ctr"/>
           <a:lstStyle/>
           <a:p>
-            <a:pPr algn="ctr" indent="0" marL="0">
+            <a:pPr marL="0" indent="0" algn="ctr">
               <a:buNone/>
             </a:pPr>
             <a:r>
@@ -7110,9 +7038,7 @@
             <a:ext cx="2743200" cy="3108960"/>
           </a:xfrm>
           <a:prstGeom prst="rect">
-            <a:avLst>
-              <a:gd name="adj" fmla="val 2667"/>
-            </a:avLst>
+            <a:avLst/>
           </a:prstGeom>
           <a:solidFill>
             <a:srgbClr val="1E2A45"/>
@@ -7124,13 +7050,20 @@
             <a:prstDash val="solid"/>
           </a:ln>
           <a:effectLst>
-            <a:outerShdw sx="100000" sy="100000" kx="0" ky="0" algn="bl" rotWithShape="0" blurRad="101600" dist="38100" dir="2700000">
+            <a:outerShdw blurRad="101600" dist="38100" dir="2700000" algn="bl" rotWithShape="0">
               <a:srgbClr val="000000">
                 <a:alpha val="35000"/>
               </a:srgbClr>
             </a:outerShdw>
           </a:effectLst>
         </p:spPr>
+        <p:txBody>
+          <a:bodyPr/>
+          <a:lstStyle/>
+          <a:p>
+            <a:endParaRPr lang="es-MX"/>
+          </a:p>
+        </p:txBody>
       </p:sp>
       <p:sp>
         <p:nvSpPr>
@@ -7153,7 +7086,7 @@
           <a:bodyPr wrap="square" rtlCol="0" anchor="ctr"/>
           <a:lstStyle/>
           <a:p>
-            <a:pPr indent="0" marL="0">
+            <a:pPr marL="0" indent="0">
               <a:buNone/>
             </a:pPr>
             <a:r>
@@ -7193,6 +7126,13 @@
             <a:prstDash val="solid"/>
           </a:ln>
         </p:spPr>
+        <p:txBody>
+          <a:bodyPr/>
+          <a:lstStyle/>
+          <a:p>
+            <a:endParaRPr lang="es-MX"/>
+          </a:p>
+        </p:txBody>
       </p:sp>
       <p:sp>
         <p:nvSpPr>
@@ -7215,7 +7155,7 @@
           <a:bodyPr wrap="square" rtlCol="0" anchor="ctr"/>
           <a:lstStyle/>
           <a:p>
-            <a:pPr indent="0" marL="0">
+            <a:pPr marL="0" indent="0">
               <a:buNone/>
             </a:pPr>
             <a:r>
@@ -7254,7 +7194,7 @@
           <a:bodyPr wrap="square" rtlCol="0" anchor="ctr"/>
           <a:lstStyle/>
           <a:p>
-            <a:pPr indent="0" marL="0">
+            <a:pPr marL="0" indent="0">
               <a:buNone/>
             </a:pPr>
             <a:r>
@@ -7293,7 +7233,7 @@
           <a:bodyPr wrap="square" rtlCol="0" anchor="ctr"/>
           <a:lstStyle/>
           <a:p>
-            <a:pPr indent="0" marL="0">
+            <a:pPr marL="0" indent="0">
               <a:buNone/>
             </a:pPr>
             <a:r>
@@ -7332,7 +7272,7 @@
           <a:bodyPr wrap="square" rtlCol="0" anchor="ctr"/>
           <a:lstStyle/>
           <a:p>
-            <a:pPr indent="0" marL="0">
+            <a:pPr marL="0" indent="0">
               <a:buNone/>
             </a:pPr>
             <a:r>
@@ -7371,7 +7311,7 @@
           <a:bodyPr wrap="square" rtlCol="0" anchor="ctr"/>
           <a:lstStyle/>
           <a:p>
-            <a:pPr indent="0" marL="0">
+            <a:pPr marL="0" indent="0">
               <a:buNone/>
             </a:pPr>
             <a:r>
@@ -7410,7 +7350,7 @@
           <a:bodyPr wrap="square" rtlCol="0" anchor="ctr"/>
           <a:lstStyle/>
           <a:p>
-            <a:pPr indent="0" marL="0">
+            <a:pPr marL="0" indent="0">
               <a:buNone/>
             </a:pPr>
             <a:r>
@@ -7449,7 +7389,7 @@
           <a:bodyPr wrap="square" rtlCol="0" anchor="ctr"/>
           <a:lstStyle/>
           <a:p>
-            <a:pPr indent="0" marL="0">
+            <a:pPr marL="0" indent="0">
               <a:buNone/>
             </a:pPr>
             <a:r>
@@ -7488,7 +7428,7 @@
           <a:bodyPr wrap="square" rtlCol="0" anchor="ctr"/>
           <a:lstStyle/>
           <a:p>
-            <a:pPr indent="0" marL="0">
+            <a:pPr marL="0" indent="0">
               <a:buNone/>
             </a:pPr>
             <a:r>
@@ -7518,9 +7458,7 @@
             <a:ext cx="2560320" cy="347472"/>
           </a:xfrm>
           <a:prstGeom prst="rect">
-            <a:avLst>
-              <a:gd name="adj" fmla="val 10526"/>
-            </a:avLst>
+            <a:avLst/>
           </a:prstGeom>
           <a:solidFill>
             <a:srgbClr val="0B0F1A"/>
@@ -7532,6 +7470,13 @@
             <a:prstDash val="solid"/>
           </a:ln>
         </p:spPr>
+        <p:txBody>
+          <a:bodyPr/>
+          <a:lstStyle/>
+          <a:p>
+            <a:endParaRPr lang="es-MX"/>
+          </a:p>
+        </p:txBody>
       </p:sp>
       <p:sp>
         <p:nvSpPr>
@@ -7554,7 +7499,7 @@
           <a:bodyPr wrap="square" rtlCol="0" anchor="ctr"/>
           <a:lstStyle/>
           <a:p>
-            <a:pPr algn="ctr" indent="0" marL="0">
+            <a:pPr marL="0" indent="0" algn="ctr">
               <a:buNone/>
             </a:pPr>
             <a:r>
@@ -7584,9 +7529,7 @@
             <a:ext cx="2743200" cy="3108960"/>
           </a:xfrm>
           <a:prstGeom prst="rect">
-            <a:avLst>
-              <a:gd name="adj" fmla="val 2667"/>
-            </a:avLst>
+            <a:avLst/>
           </a:prstGeom>
           <a:solidFill>
             <a:srgbClr val="1E2A45"/>
@@ -7598,13 +7541,20 @@
             <a:prstDash val="solid"/>
           </a:ln>
           <a:effectLst>
-            <a:outerShdw sx="100000" sy="100000" kx="0" ky="0" algn="bl" rotWithShape="0" blurRad="101600" dist="38100" dir="2700000">
+            <a:outerShdw blurRad="101600" dist="38100" dir="2700000" algn="bl" rotWithShape="0">
               <a:srgbClr val="000000">
                 <a:alpha val="35000"/>
               </a:srgbClr>
             </a:outerShdw>
           </a:effectLst>
         </p:spPr>
+        <p:txBody>
+          <a:bodyPr/>
+          <a:lstStyle/>
+          <a:p>
+            <a:endParaRPr lang="es-MX"/>
+          </a:p>
+        </p:txBody>
       </p:sp>
       <p:sp>
         <p:nvSpPr>
@@ -7627,7 +7577,7 @@
           <a:bodyPr wrap="square" rtlCol="0" anchor="ctr"/>
           <a:lstStyle/>
           <a:p>
-            <a:pPr indent="0" marL="0">
+            <a:pPr marL="0" indent="0">
               <a:buNone/>
             </a:pPr>
             <a:r>
@@ -7667,6 +7617,13 @@
             <a:prstDash val="solid"/>
           </a:ln>
         </p:spPr>
+        <p:txBody>
+          <a:bodyPr/>
+          <a:lstStyle/>
+          <a:p>
+            <a:endParaRPr lang="es-MX"/>
+          </a:p>
+        </p:txBody>
       </p:sp>
       <p:sp>
         <p:nvSpPr>
@@ -7689,7 +7646,7 @@
           <a:bodyPr wrap="square" rtlCol="0" anchor="ctr"/>
           <a:lstStyle/>
           <a:p>
-            <a:pPr indent="0" marL="0">
+            <a:pPr marL="0" indent="0">
               <a:buNone/>
             </a:pPr>
             <a:r>
@@ -7728,7 +7685,7 @@
           <a:bodyPr wrap="square" rtlCol="0" anchor="ctr"/>
           <a:lstStyle/>
           <a:p>
-            <a:pPr indent="0" marL="0">
+            <a:pPr marL="0" indent="0">
               <a:buNone/>
             </a:pPr>
             <a:r>
@@ -7767,7 +7724,7 @@
           <a:bodyPr wrap="square" rtlCol="0" anchor="ctr"/>
           <a:lstStyle/>
           <a:p>
-            <a:pPr indent="0" marL="0">
+            <a:pPr marL="0" indent="0">
               <a:buNone/>
             </a:pPr>
             <a:r>
@@ -7806,7 +7763,7 @@
           <a:bodyPr wrap="square" rtlCol="0" anchor="ctr"/>
           <a:lstStyle/>
           <a:p>
-            <a:pPr indent="0" marL="0">
+            <a:pPr marL="0" indent="0">
               <a:buNone/>
             </a:pPr>
             <a:r>
@@ -7845,7 +7802,7 @@
           <a:bodyPr wrap="square" rtlCol="0" anchor="ctr"/>
           <a:lstStyle/>
           <a:p>
-            <a:pPr indent="0" marL="0">
+            <a:pPr marL="0" indent="0">
               <a:buNone/>
             </a:pPr>
             <a:r>
@@ -7884,7 +7841,7 @@
           <a:bodyPr wrap="square" rtlCol="0" anchor="ctr"/>
           <a:lstStyle/>
           <a:p>
-            <a:pPr indent="0" marL="0">
+            <a:pPr marL="0" indent="0">
               <a:buNone/>
             </a:pPr>
             <a:r>
@@ -7923,7 +7880,7 @@
           <a:bodyPr wrap="square" rtlCol="0" anchor="ctr"/>
           <a:lstStyle/>
           <a:p>
-            <a:pPr indent="0" marL="0">
+            <a:pPr marL="0" indent="0">
               <a:buNone/>
             </a:pPr>
             <a:r>
@@ -7962,7 +7919,7 @@
           <a:bodyPr wrap="square" rtlCol="0" anchor="ctr"/>
           <a:lstStyle/>
           <a:p>
-            <a:pPr indent="0" marL="0">
+            <a:pPr marL="0" indent="0">
               <a:buNone/>
             </a:pPr>
             <a:r>
@@ -7992,9 +7949,7 @@
             <a:ext cx="2560320" cy="347472"/>
           </a:xfrm>
           <a:prstGeom prst="rect">
-            <a:avLst>
-              <a:gd name="adj" fmla="val 10526"/>
-            </a:avLst>
+            <a:avLst/>
           </a:prstGeom>
           <a:solidFill>
             <a:srgbClr val="0B0F1A"/>
@@ -8006,6 +7961,13 @@
             <a:prstDash val="solid"/>
           </a:ln>
         </p:spPr>
+        <p:txBody>
+          <a:bodyPr/>
+          <a:lstStyle/>
+          <a:p>
+            <a:endParaRPr lang="es-MX"/>
+          </a:p>
+        </p:txBody>
       </p:sp>
       <p:sp>
         <p:nvSpPr>
@@ -8028,7 +7990,7 @@
           <a:bodyPr wrap="square" rtlCol="0" anchor="ctr"/>
           <a:lstStyle/>
           <a:p>
-            <a:pPr algn="ctr" indent="0" marL="0">
+            <a:pPr marL="0" indent="0" algn="ctr">
               <a:buNone/>
             </a:pPr>
             <a:r>
@@ -8058,9 +8020,7 @@
             <a:ext cx="8412480" cy="475488"/>
           </a:xfrm>
           <a:prstGeom prst="rect">
-            <a:avLst>
-              <a:gd name="adj" fmla="val 7692"/>
-            </a:avLst>
+            <a:avLst/>
           </a:prstGeom>
           <a:solidFill>
             <a:srgbClr val="1E2A45"/>
@@ -8072,6 +8032,13 @@
             <a:prstDash val="solid"/>
           </a:ln>
         </p:spPr>
+        <p:txBody>
+          <a:bodyPr/>
+          <a:lstStyle/>
+          <a:p>
+            <a:endParaRPr lang="es-MX"/>
+          </a:p>
+        </p:txBody>
       </p:sp>
       <p:sp>
         <p:nvSpPr>
@@ -8085,9 +8052,7 @@
             <a:ext cx="8269468" cy="475488"/>
           </a:xfrm>
           <a:prstGeom prst="rect">
-            <a:avLst>
-              <a:gd name="adj" fmla="val 7692"/>
-            </a:avLst>
+            <a:avLst/>
           </a:prstGeom>
           <a:solidFill>
             <a:srgbClr val="4ADE80"/>
@@ -8099,6 +8064,13 @@
             <a:prstDash val="solid"/>
           </a:ln>
         </p:spPr>
+        <p:txBody>
+          <a:bodyPr/>
+          <a:lstStyle/>
+          <a:p>
+            <a:endParaRPr lang="es-MX"/>
+          </a:p>
+        </p:txBody>
       </p:sp>
       <p:sp>
         <p:nvSpPr>
@@ -8121,7 +8093,7 @@
           <a:bodyPr wrap="square" rtlCol="0" anchor="ctr"/>
           <a:lstStyle/>
           <a:p>
-            <a:pPr algn="ctr" indent="0" marL="0">
+            <a:pPr marL="0" indent="0" algn="ctr">
               <a:buNone/>
             </a:pPr>
             <a:r>
@@ -8155,6 +8127,7 @@
         <a:solidFill>
           <a:srgbClr val="0B0F1A"/>
         </a:solidFill>
+        <a:effectLst/>
       </p:bgPr>
     </p:bg>
     <p:spTree>
@@ -8192,7 +8165,7 @@
           <a:bodyPr wrap="square" rtlCol="0" anchor="ctr"/>
           <a:lstStyle/>
           <a:p>
-            <a:pPr algn="ctr" indent="0" marL="0">
+            <a:pPr marL="0" indent="0" algn="ctr">
               <a:buNone/>
             </a:pPr>
             <a:r>
@@ -8231,7 +8204,7 @@
           <a:bodyPr wrap="square" rtlCol="0" anchor="ctr"/>
           <a:lstStyle/>
           <a:p>
-            <a:pPr algn="ctr" indent="0" marL="0">
+            <a:pPr marL="0" indent="0" algn="ctr">
               <a:buNone/>
             </a:pPr>
             <a:r>
@@ -8270,7 +8243,7 @@
           <a:bodyPr wrap="square" rtlCol="0" anchor="ctr"/>
           <a:lstStyle/>
           <a:p>
-            <a:pPr algn="ctr" indent="0" marL="0">
+            <a:pPr marL="0" indent="0" algn="ctr">
               <a:buNone/>
             </a:pPr>
             <a:r>
@@ -8312,6 +8285,13 @@
             <a:prstDash val="solid"/>
           </a:ln>
         </p:spPr>
+        <p:txBody>
+          <a:bodyPr/>
+          <a:lstStyle/>
+          <a:p>
+            <a:endParaRPr lang="es-MX"/>
+          </a:p>
+        </p:txBody>
       </p:sp>
       <p:sp>
         <p:nvSpPr>
@@ -8337,6 +8317,13 @@
             <a:prstDash val="solid"/>
           </a:ln>
         </p:spPr>
+        <p:txBody>
+          <a:bodyPr/>
+          <a:lstStyle/>
+          <a:p>
+            <a:endParaRPr lang="es-MX"/>
+          </a:p>
+        </p:txBody>
       </p:sp>
       <p:sp>
         <p:nvSpPr>
@@ -8362,6 +8349,13 @@
             <a:prstDash val="solid"/>
           </a:ln>
         </p:spPr>
+        <p:txBody>
+          <a:bodyPr/>
+          <a:lstStyle/>
+          <a:p>
+            <a:endParaRPr lang="es-MX"/>
+          </a:p>
+        </p:txBody>
       </p:sp>
       <p:sp>
         <p:nvSpPr>
@@ -8387,6 +8381,13 @@
             <a:prstDash val="solid"/>
           </a:ln>
         </p:spPr>
+        <p:txBody>
+          <a:bodyPr/>
+          <a:lstStyle/>
+          <a:p>
+            <a:endParaRPr lang="es-MX"/>
+          </a:p>
+        </p:txBody>
       </p:sp>
       <p:sp>
         <p:nvSpPr>
@@ -8412,6 +8413,13 @@
             <a:prstDash val="solid"/>
           </a:ln>
         </p:spPr>
+        <p:txBody>
+          <a:bodyPr/>
+          <a:lstStyle/>
+          <a:p>
+            <a:endParaRPr lang="es-MX"/>
+          </a:p>
+        </p:txBody>
       </p:sp>
       <p:sp>
         <p:nvSpPr>
@@ -8437,6 +8445,13 @@
             <a:prstDash val="solid"/>
           </a:ln>
         </p:spPr>
+        <p:txBody>
+          <a:bodyPr/>
+          <a:lstStyle/>
+          <a:p>
+            <a:endParaRPr lang="es-MX"/>
+          </a:p>
+        </p:txBody>
       </p:sp>
     </p:spTree>
   </p:cSld>
@@ -8454,6 +8469,7 @@
         <a:solidFill>
           <a:srgbClr val="141929"/>
         </a:solidFill>
+        <a:effectLst/>
       </p:bgPr>
     </p:bg>
     <p:spTree>
@@ -8494,6 +8510,13 @@
             <a:prstDash val="solid"/>
           </a:ln>
         </p:spPr>
+        <p:txBody>
+          <a:bodyPr/>
+          <a:lstStyle/>
+          <a:p>
+            <a:endParaRPr lang="es-MX"/>
+          </a:p>
+        </p:txBody>
       </p:sp>
       <p:sp>
         <p:nvSpPr>
@@ -8516,7 +8539,7 @@
           <a:bodyPr wrap="square" rtlCol="0" anchor="ctr"/>
           <a:lstStyle/>
           <a:p>
-            <a:pPr indent="0" marL="0">
+            <a:pPr marL="0" indent="0">
               <a:buNone/>
             </a:pPr>
             <a:r>
@@ -8546,9 +8569,7 @@
             <a:ext cx="347472" cy="292608"/>
           </a:xfrm>
           <a:prstGeom prst="rect">
-            <a:avLst>
-              <a:gd name="adj" fmla="val 18750"/>
-            </a:avLst>
+            <a:avLst/>
           </a:prstGeom>
           <a:solidFill>
             <a:srgbClr val="4ADE80"/>
@@ -8560,6 +8581,13 @@
             <a:prstDash val="solid"/>
           </a:ln>
         </p:spPr>
+        <p:txBody>
+          <a:bodyPr/>
+          <a:lstStyle/>
+          <a:p>
+            <a:endParaRPr lang="es-MX"/>
+          </a:p>
+        </p:txBody>
       </p:sp>
       <p:sp>
         <p:nvSpPr>
@@ -8582,7 +8610,7 @@
           <a:bodyPr wrap="square" rtlCol="0" anchor="ctr"/>
           <a:lstStyle/>
           <a:p>
-            <a:pPr algn="ctr" indent="0" marL="0">
+            <a:pPr marL="0" indent="0" algn="ctr">
               <a:buNone/>
             </a:pPr>
             <a:r>
@@ -8621,7 +8649,7 @@
           <a:bodyPr wrap="square" rtlCol="0" anchor="ctr"/>
           <a:lstStyle/>
           <a:p>
-            <a:pPr indent="0" marL="0">
+            <a:pPr marL="0" indent="0">
               <a:buNone/>
             </a:pPr>
             <a:r>
@@ -8651,9 +8679,7 @@
             <a:ext cx="347472" cy="292608"/>
           </a:xfrm>
           <a:prstGeom prst="rect">
-            <a:avLst>
-              <a:gd name="adj" fmla="val 18750"/>
-            </a:avLst>
+            <a:avLst/>
           </a:prstGeom>
           <a:solidFill>
             <a:srgbClr val="4ADE80"/>
@@ -8665,6 +8691,13 @@
             <a:prstDash val="solid"/>
           </a:ln>
         </p:spPr>
+        <p:txBody>
+          <a:bodyPr/>
+          <a:lstStyle/>
+          <a:p>
+            <a:endParaRPr lang="es-MX"/>
+          </a:p>
+        </p:txBody>
       </p:sp>
       <p:sp>
         <p:nvSpPr>
@@ -8687,7 +8720,7 @@
           <a:bodyPr wrap="square" rtlCol="0" anchor="ctr"/>
           <a:lstStyle/>
           <a:p>
-            <a:pPr algn="ctr" indent="0" marL="0">
+            <a:pPr marL="0" indent="0" algn="ctr">
               <a:buNone/>
             </a:pPr>
             <a:r>
@@ -8726,7 +8759,7 @@
           <a:bodyPr wrap="square" rtlCol="0" anchor="ctr"/>
           <a:lstStyle/>
           <a:p>
-            <a:pPr indent="0" marL="0">
+            <a:pPr marL="0" indent="0">
               <a:buNone/>
             </a:pPr>
             <a:r>
@@ -8756,9 +8789,7 @@
             <a:ext cx="347472" cy="292608"/>
           </a:xfrm>
           <a:prstGeom prst="rect">
-            <a:avLst>
-              <a:gd name="adj" fmla="val 18750"/>
-            </a:avLst>
+            <a:avLst/>
           </a:prstGeom>
           <a:solidFill>
             <a:srgbClr val="4ADE80"/>
@@ -8770,6 +8801,13 @@
             <a:prstDash val="solid"/>
           </a:ln>
         </p:spPr>
+        <p:txBody>
+          <a:bodyPr/>
+          <a:lstStyle/>
+          <a:p>
+            <a:endParaRPr lang="es-MX"/>
+          </a:p>
+        </p:txBody>
       </p:sp>
       <p:sp>
         <p:nvSpPr>
@@ -8792,7 +8830,7 @@
           <a:bodyPr wrap="square" rtlCol="0" anchor="ctr"/>
           <a:lstStyle/>
           <a:p>
-            <a:pPr algn="ctr" indent="0" marL="0">
+            <a:pPr marL="0" indent="0" algn="ctr">
               <a:buNone/>
             </a:pPr>
             <a:r>
@@ -8831,7 +8869,7 @@
           <a:bodyPr wrap="square" rtlCol="0" anchor="ctr"/>
           <a:lstStyle/>
           <a:p>
-            <a:pPr indent="0" marL="0">
+            <a:pPr marL="0" indent="0">
               <a:buNone/>
             </a:pPr>
             <a:r>
@@ -8861,9 +8899,7 @@
             <a:ext cx="347472" cy="292608"/>
           </a:xfrm>
           <a:prstGeom prst="rect">
-            <a:avLst>
-              <a:gd name="adj" fmla="val 18750"/>
-            </a:avLst>
+            <a:avLst/>
           </a:prstGeom>
           <a:solidFill>
             <a:srgbClr val="4ADE80"/>
@@ -8875,6 +8911,13 @@
             <a:prstDash val="solid"/>
           </a:ln>
         </p:spPr>
+        <p:txBody>
+          <a:bodyPr/>
+          <a:lstStyle/>
+          <a:p>
+            <a:endParaRPr lang="es-MX"/>
+          </a:p>
+        </p:txBody>
       </p:sp>
       <p:sp>
         <p:nvSpPr>
@@ -8897,7 +8940,7 @@
           <a:bodyPr wrap="square" rtlCol="0" anchor="ctr"/>
           <a:lstStyle/>
           <a:p>
-            <a:pPr algn="ctr" indent="0" marL="0">
+            <a:pPr marL="0" indent="0" algn="ctr">
               <a:buNone/>
             </a:pPr>
             <a:r>
@@ -8936,7 +8979,7 @@
           <a:bodyPr wrap="square" rtlCol="0" anchor="ctr"/>
           <a:lstStyle/>
           <a:p>
-            <a:pPr indent="0" marL="0">
+            <a:pPr marL="0" indent="0">
               <a:buNone/>
             </a:pPr>
             <a:r>
@@ -8966,9 +9009,7 @@
             <a:ext cx="347472" cy="292608"/>
           </a:xfrm>
           <a:prstGeom prst="rect">
-            <a:avLst>
-              <a:gd name="adj" fmla="val 18750"/>
-            </a:avLst>
+            <a:avLst/>
           </a:prstGeom>
           <a:solidFill>
             <a:srgbClr val="4ADE80"/>
@@ -8980,6 +9021,13 @@
             <a:prstDash val="solid"/>
           </a:ln>
         </p:spPr>
+        <p:txBody>
+          <a:bodyPr/>
+          <a:lstStyle/>
+          <a:p>
+            <a:endParaRPr lang="es-MX"/>
+          </a:p>
+        </p:txBody>
       </p:sp>
       <p:sp>
         <p:nvSpPr>
@@ -9002,7 +9050,7 @@
           <a:bodyPr wrap="square" rtlCol="0" anchor="ctr"/>
           <a:lstStyle/>
           <a:p>
-            <a:pPr algn="ctr" indent="0" marL="0">
+            <a:pPr marL="0" indent="0" algn="ctr">
               <a:buNone/>
             </a:pPr>
             <a:r>
@@ -9041,7 +9089,7 @@
           <a:bodyPr wrap="square" rtlCol="0" anchor="ctr"/>
           <a:lstStyle/>
           <a:p>
-            <a:pPr indent="0" marL="0">
+            <a:pPr marL="0" indent="0">
               <a:buNone/>
             </a:pPr>
             <a:r>
@@ -9071,9 +9119,7 @@
             <a:ext cx="347472" cy="292608"/>
           </a:xfrm>
           <a:prstGeom prst="rect">
-            <a:avLst>
-              <a:gd name="adj" fmla="val 18750"/>
-            </a:avLst>
+            <a:avLst/>
           </a:prstGeom>
           <a:solidFill>
             <a:srgbClr val="4ADE80"/>
@@ -9085,6 +9131,13 @@
             <a:prstDash val="solid"/>
           </a:ln>
         </p:spPr>
+        <p:txBody>
+          <a:bodyPr/>
+          <a:lstStyle/>
+          <a:p>
+            <a:endParaRPr lang="es-MX"/>
+          </a:p>
+        </p:txBody>
       </p:sp>
       <p:sp>
         <p:nvSpPr>
@@ -9107,7 +9160,7 @@
           <a:bodyPr wrap="square" rtlCol="0" anchor="ctr"/>
           <a:lstStyle/>
           <a:p>
-            <a:pPr algn="ctr" indent="0" marL="0">
+            <a:pPr marL="0" indent="0" algn="ctr">
               <a:buNone/>
             </a:pPr>
             <a:r>
@@ -9146,7 +9199,7 @@
           <a:bodyPr wrap="square" rtlCol="0" anchor="ctr"/>
           <a:lstStyle/>
           <a:p>
-            <a:pPr indent="0" marL="0">
+            <a:pPr marL="0" indent="0">
               <a:buNone/>
             </a:pPr>
             <a:r>
@@ -9176,9 +9229,7 @@
             <a:ext cx="347472" cy="292608"/>
           </a:xfrm>
           <a:prstGeom prst="rect">
-            <a:avLst>
-              <a:gd name="adj" fmla="val 18750"/>
-            </a:avLst>
+            <a:avLst/>
           </a:prstGeom>
           <a:solidFill>
             <a:srgbClr val="4ADE80"/>
@@ -9190,6 +9241,13 @@
             <a:prstDash val="solid"/>
           </a:ln>
         </p:spPr>
+        <p:txBody>
+          <a:bodyPr/>
+          <a:lstStyle/>
+          <a:p>
+            <a:endParaRPr lang="es-MX"/>
+          </a:p>
+        </p:txBody>
       </p:sp>
       <p:sp>
         <p:nvSpPr>
@@ -9212,7 +9270,7 @@
           <a:bodyPr wrap="square" rtlCol="0" anchor="ctr"/>
           <a:lstStyle/>
           <a:p>
-            <a:pPr algn="ctr" indent="0" marL="0">
+            <a:pPr marL="0" indent="0" algn="ctr">
               <a:buNone/>
             </a:pPr>
             <a:r>
@@ -9251,7 +9309,7 @@
           <a:bodyPr wrap="square" rtlCol="0" anchor="ctr"/>
           <a:lstStyle/>
           <a:p>
-            <a:pPr indent="0" marL="0">
+            <a:pPr marL="0" indent="0">
               <a:buNone/>
             </a:pPr>
             <a:r>
@@ -9281,9 +9339,7 @@
             <a:ext cx="347472" cy="292608"/>
           </a:xfrm>
           <a:prstGeom prst="rect">
-            <a:avLst>
-              <a:gd name="adj" fmla="val 18750"/>
-            </a:avLst>
+            <a:avLst/>
           </a:prstGeom>
           <a:solidFill>
             <a:srgbClr val="4ADE80"/>
@@ -9295,6 +9351,13 @@
             <a:prstDash val="solid"/>
           </a:ln>
         </p:spPr>
+        <p:txBody>
+          <a:bodyPr/>
+          <a:lstStyle/>
+          <a:p>
+            <a:endParaRPr lang="es-MX"/>
+          </a:p>
+        </p:txBody>
       </p:sp>
       <p:sp>
         <p:nvSpPr>
@@ -9317,7 +9380,7 @@
           <a:bodyPr wrap="square" rtlCol="0" anchor="ctr"/>
           <a:lstStyle/>
           <a:p>
-            <a:pPr algn="ctr" indent="0" marL="0">
+            <a:pPr marL="0" indent="0" algn="ctr">
               <a:buNone/>
             </a:pPr>
             <a:r>
@@ -9356,7 +9419,7 @@
           <a:bodyPr wrap="square" rtlCol="0" anchor="ctr"/>
           <a:lstStyle/>
           <a:p>
-            <a:pPr indent="0" marL="0">
+            <a:pPr marL="0" indent="0">
               <a:buNone/>
             </a:pPr>
             <a:r>
@@ -9386,9 +9449,7 @@
             <a:ext cx="347472" cy="292608"/>
           </a:xfrm>
           <a:prstGeom prst="rect">
-            <a:avLst>
-              <a:gd name="adj" fmla="val 18750"/>
-            </a:avLst>
+            <a:avLst/>
           </a:prstGeom>
           <a:solidFill>
             <a:srgbClr val="4ADE80"/>
@@ -9400,6 +9461,13 @@
             <a:prstDash val="solid"/>
           </a:ln>
         </p:spPr>
+        <p:txBody>
+          <a:bodyPr/>
+          <a:lstStyle/>
+          <a:p>
+            <a:endParaRPr lang="es-MX"/>
+          </a:p>
+        </p:txBody>
       </p:sp>
       <p:sp>
         <p:nvSpPr>
@@ -9422,7 +9490,7 @@
           <a:bodyPr wrap="square" rtlCol="0" anchor="ctr"/>
           <a:lstStyle/>
           <a:p>
-            <a:pPr algn="ctr" indent="0" marL="0">
+            <a:pPr marL="0" indent="0" algn="ctr">
               <a:buNone/>
             </a:pPr>
             <a:r>
@@ -9461,7 +9529,7 @@
           <a:bodyPr wrap="square" rtlCol="0" anchor="ctr"/>
           <a:lstStyle/>
           <a:p>
-            <a:pPr indent="0" marL="0">
+            <a:pPr marL="0" indent="0">
               <a:buNone/>
             </a:pPr>
             <a:r>
@@ -9491,9 +9559,7 @@
             <a:ext cx="347472" cy="292608"/>
           </a:xfrm>
           <a:prstGeom prst="rect">
-            <a:avLst>
-              <a:gd name="adj" fmla="val 18750"/>
-            </a:avLst>
+            <a:avLst/>
           </a:prstGeom>
           <a:solidFill>
             <a:srgbClr val="4ADE80"/>
@@ -9505,6 +9571,13 @@
             <a:prstDash val="solid"/>
           </a:ln>
         </p:spPr>
+        <p:txBody>
+          <a:bodyPr/>
+          <a:lstStyle/>
+          <a:p>
+            <a:endParaRPr lang="es-MX"/>
+          </a:p>
+        </p:txBody>
       </p:sp>
       <p:sp>
         <p:nvSpPr>
@@ -9527,7 +9600,7 @@
           <a:bodyPr wrap="square" rtlCol="0" anchor="ctr"/>
           <a:lstStyle/>
           <a:p>
-            <a:pPr algn="ctr" indent="0" marL="0">
+            <a:pPr marL="0" indent="0" algn="ctr">
               <a:buNone/>
             </a:pPr>
             <a:r>
@@ -9566,7 +9639,7 @@
           <a:bodyPr wrap="square" rtlCol="0" anchor="ctr"/>
           <a:lstStyle/>
           <a:p>
-            <a:pPr indent="0" marL="0">
+            <a:pPr marL="0" indent="0">
               <a:buNone/>
             </a:pPr>
             <a:r>
@@ -9600,6 +9673,7 @@
         <a:solidFill>
           <a:srgbClr val="141929"/>
         </a:solidFill>
+        <a:effectLst/>
       </p:bgPr>
     </p:bg>
     <p:spTree>
@@ -9640,17 +9714,24 @@
             <a:prstDash val="solid"/>
           </a:ln>
         </p:spPr>
+        <p:txBody>
+          <a:bodyPr/>
+          <a:lstStyle/>
+          <a:p>
+            <a:endParaRPr lang="es-MX"/>
+          </a:p>
+        </p:txBody>
       </p:sp>
       <p:pic>
         <p:nvPicPr>
-          <p:cNvPr id="3" name="Image 0" descr="C:\Users\JoseRamonEstradaRend\AppData\Roaming\Claude\local-agent-mode-sessions\skills-plugin\d7d799c7-c68d-4735-9f18-5020fbbe8e77\246afd61-2015-4905-b7d3-2bf63e539570\skills\pptx\screenshots\01_dashboard.jpg">    </p:cNvPr>
+          <p:cNvPr id="3" name="Image 0" descr="C:\Users\JoseRamonEstradaRend\AppData\Roaming\Claude\local-agent-mode-sessions\skills-plugin\d7d799c7-c68d-4735-9f18-5020fbbe8e77\246afd61-2015-4905-b7d3-2bf63e539570\skills\pptx\screenshots\01_dashboard.jpg"/>
           <p:cNvPicPr>
             <a:picLocks noChangeAspect="1"/>
           </p:cNvPicPr>
           <p:nvPr/>
         </p:nvPicPr>
         <p:blipFill>
-          <a:blip r:embed="rId1"/>
+          <a:blip r:embed="rId3"/>
           <a:stretch>
             <a:fillRect/>
           </a:stretch>
@@ -9664,7 +9745,7 @@
             <a:avLst/>
           </a:prstGeom>
           <a:effectLst>
-            <a:outerShdw sx="100000" sy="100000" kx="0" ky="0" algn="bl" rotWithShape="0" blurRad="152400" dist="50800" dir="2700000">
+            <a:outerShdw blurRad="152400" dist="50800" dir="2700000" algn="bl" rotWithShape="0">
               <a:srgbClr val="000000">
                 <a:alpha val="55000"/>
               </a:srgbClr>
@@ -9684,9 +9765,7 @@
             <a:ext cx="384048" cy="256032"/>
           </a:xfrm>
           <a:prstGeom prst="rect">
-            <a:avLst>
-              <a:gd name="adj" fmla="val 14286"/>
-            </a:avLst>
+            <a:avLst/>
           </a:prstGeom>
           <a:solidFill>
             <a:srgbClr val="4ADE80"/>
@@ -9698,6 +9777,13 @@
             <a:prstDash val="solid"/>
           </a:ln>
         </p:spPr>
+        <p:txBody>
+          <a:bodyPr/>
+          <a:lstStyle/>
+          <a:p>
+            <a:endParaRPr lang="es-MX"/>
+          </a:p>
+        </p:txBody>
       </p:sp>
       <p:sp>
         <p:nvSpPr>
@@ -9720,7 +9806,7 @@
           <a:bodyPr wrap="square" rtlCol="0" anchor="ctr"/>
           <a:lstStyle/>
           <a:p>
-            <a:pPr algn="ctr" indent="0" marL="0">
+            <a:pPr marL="0" indent="0" algn="ctr">
               <a:buNone/>
             </a:pPr>
             <a:r>
@@ -9761,7 +9847,7 @@
           </a:bodyPr>
           <a:lstStyle/>
           <a:p>
-            <a:pPr indent="0" marL="0">
+            <a:pPr marL="0" indent="0">
               <a:buNone/>
             </a:pPr>
             <a:r>
@@ -9801,6 +9887,13 @@
             <a:prstDash val="solid"/>
           </a:ln>
         </p:spPr>
+        <p:txBody>
+          <a:bodyPr/>
+          <a:lstStyle/>
+          <a:p>
+            <a:endParaRPr lang="es-MX"/>
+          </a:p>
+        </p:txBody>
       </p:sp>
       <p:sp>
         <p:nvSpPr>
@@ -9823,7 +9916,7 @@
           <a:bodyPr wrap="square" rtlCol="0" anchor="t"/>
           <a:lstStyle/>
           <a:p>
-            <a:pPr indent="0" marL="0">
+            <a:pPr marL="0" indent="0">
               <a:buNone/>
             </a:pPr>
             <a:r>
@@ -9862,7 +9955,7 @@
           <a:bodyPr wrap="square" rtlCol="0" anchor="t"/>
           <a:lstStyle/>
           <a:p>
-            <a:pPr indent="0" marL="0">
+            <a:pPr marL="0" indent="0">
               <a:buNone/>
             </a:pPr>
             <a:r>
@@ -9901,7 +9994,7 @@
           <a:bodyPr wrap="square" rtlCol="0" anchor="t"/>
           <a:lstStyle/>
           <a:p>
-            <a:pPr indent="0" marL="0">
+            <a:pPr marL="0" indent="0">
               <a:buNone/>
             </a:pPr>
             <a:r>
@@ -9940,7 +10033,7 @@
           <a:bodyPr wrap="square" rtlCol="0" anchor="t"/>
           <a:lstStyle/>
           <a:p>
-            <a:pPr indent="0" marL="0">
+            <a:pPr marL="0" indent="0">
               <a:buNone/>
             </a:pPr>
             <a:r>
@@ -9974,6 +10067,7 @@
         <a:solidFill>
           <a:srgbClr val="141929"/>
         </a:solidFill>
+        <a:effectLst/>
       </p:bgPr>
     </p:bg>
     <p:spTree>
@@ -10014,17 +10108,24 @@
             <a:prstDash val="solid"/>
           </a:ln>
         </p:spPr>
+        <p:txBody>
+          <a:bodyPr/>
+          <a:lstStyle/>
+          <a:p>
+            <a:endParaRPr lang="es-MX"/>
+          </a:p>
+        </p:txBody>
       </p:sp>
       <p:pic>
         <p:nvPicPr>
-          <p:cNvPr id="3" name="Image 0" descr="C:\Users\JoseRamonEstradaRend\AppData\Roaming\Claude\local-agent-mode-sessions\skills-plugin\d7d799c7-c68d-4735-9f18-5020fbbe8e77\246afd61-2015-4905-b7d3-2bf63e539570\skills\pptx\screenshots\02_registros.jpg">    </p:cNvPr>
+          <p:cNvPr id="3" name="Image 0" descr="C:\Users\JoseRamonEstradaRend\AppData\Roaming\Claude\local-agent-mode-sessions\skills-plugin\d7d799c7-c68d-4735-9f18-5020fbbe8e77\246afd61-2015-4905-b7d3-2bf63e539570\skills\pptx\screenshots\02_registros.jpg"/>
           <p:cNvPicPr>
             <a:picLocks noChangeAspect="1"/>
           </p:cNvPicPr>
           <p:nvPr/>
         </p:nvPicPr>
         <p:blipFill>
-          <a:blip r:embed="rId1"/>
+          <a:blip r:embed="rId3"/>
           <a:stretch>
             <a:fillRect/>
           </a:stretch>
@@ -10038,7 +10139,7 @@
             <a:avLst/>
           </a:prstGeom>
           <a:effectLst>
-            <a:outerShdw sx="100000" sy="100000" kx="0" ky="0" algn="bl" rotWithShape="0" blurRad="152400" dist="50800" dir="2700000">
+            <a:outerShdw blurRad="152400" dist="50800" dir="2700000" algn="bl" rotWithShape="0">
               <a:srgbClr val="000000">
                 <a:alpha val="55000"/>
               </a:srgbClr>
@@ -10058,9 +10159,7 @@
             <a:ext cx="384048" cy="256032"/>
           </a:xfrm>
           <a:prstGeom prst="rect">
-            <a:avLst>
-              <a:gd name="adj" fmla="val 14286"/>
-            </a:avLst>
+            <a:avLst/>
           </a:prstGeom>
           <a:solidFill>
             <a:srgbClr val="4ADE80"/>
@@ -10072,6 +10171,13 @@
             <a:prstDash val="solid"/>
           </a:ln>
         </p:spPr>
+        <p:txBody>
+          <a:bodyPr/>
+          <a:lstStyle/>
+          <a:p>
+            <a:endParaRPr lang="es-MX"/>
+          </a:p>
+        </p:txBody>
       </p:sp>
       <p:sp>
         <p:nvSpPr>
@@ -10094,7 +10200,7 @@
           <a:bodyPr wrap="square" rtlCol="0" anchor="ctr"/>
           <a:lstStyle/>
           <a:p>
-            <a:pPr algn="ctr" indent="0" marL="0">
+            <a:pPr marL="0" indent="0" algn="ctr">
               <a:buNone/>
             </a:pPr>
             <a:r>
@@ -10135,7 +10241,7 @@
           </a:bodyPr>
           <a:lstStyle/>
           <a:p>
-            <a:pPr indent="0" marL="0">
+            <a:pPr marL="0" indent="0">
               <a:buNone/>
             </a:pPr>
             <a:r>
@@ -10175,6 +10281,13 @@
             <a:prstDash val="solid"/>
           </a:ln>
         </p:spPr>
+        <p:txBody>
+          <a:bodyPr/>
+          <a:lstStyle/>
+          <a:p>
+            <a:endParaRPr lang="es-MX"/>
+          </a:p>
+        </p:txBody>
       </p:sp>
       <p:sp>
         <p:nvSpPr>
@@ -10197,7 +10310,7 @@
           <a:bodyPr wrap="square" rtlCol="0" anchor="t"/>
           <a:lstStyle/>
           <a:p>
-            <a:pPr indent="0" marL="0">
+            <a:pPr marL="0" indent="0">
               <a:buNone/>
             </a:pPr>
             <a:r>
@@ -10236,7 +10349,7 @@
           <a:bodyPr wrap="square" rtlCol="0" anchor="t"/>
           <a:lstStyle/>
           <a:p>
-            <a:pPr indent="0" marL="0">
+            <a:pPr marL="0" indent="0">
               <a:buNone/>
             </a:pPr>
             <a:r>
@@ -10275,7 +10388,7 @@
           <a:bodyPr wrap="square" rtlCol="0" anchor="t"/>
           <a:lstStyle/>
           <a:p>
-            <a:pPr indent="0" marL="0">
+            <a:pPr marL="0" indent="0">
               <a:buNone/>
             </a:pPr>
             <a:r>
@@ -10314,7 +10427,7 @@
           <a:bodyPr wrap="square" rtlCol="0" anchor="t"/>
           <a:lstStyle/>
           <a:p>
-            <a:pPr indent="0" marL="0">
+            <a:pPr marL="0" indent="0">
               <a:buNone/>
             </a:pPr>
             <a:r>
@@ -10348,6 +10461,7 @@
         <a:solidFill>
           <a:srgbClr val="141929"/>
         </a:solidFill>
+        <a:effectLst/>
       </p:bgPr>
     </p:bg>
     <p:spTree>
@@ -10388,17 +10502,24 @@
             <a:prstDash val="solid"/>
           </a:ln>
         </p:spPr>
+        <p:txBody>
+          <a:bodyPr/>
+          <a:lstStyle/>
+          <a:p>
+            <a:endParaRPr lang="es-MX"/>
+          </a:p>
+        </p:txBody>
       </p:sp>
       <p:pic>
         <p:nvPicPr>
-          <p:cNvPr id="3" name="Image 0" descr="C:\Users\JoseRamonEstradaRend\AppData\Roaming\Claude\local-agent-mode-sessions\skills-plugin\d7d799c7-c68d-4735-9f18-5020fbbe8e77\246afd61-2015-4905-b7d3-2bf63e539570\skills\pptx\screenshots\03_reportes.jpg">    </p:cNvPr>
+          <p:cNvPr id="3" name="Image 0" descr="C:\Users\JoseRamonEstradaRend\AppData\Roaming\Claude\local-agent-mode-sessions\skills-plugin\d7d799c7-c68d-4735-9f18-5020fbbe8e77\246afd61-2015-4905-b7d3-2bf63e539570\skills\pptx\screenshots\03_reportes.jpg"/>
           <p:cNvPicPr>
             <a:picLocks noChangeAspect="1"/>
           </p:cNvPicPr>
           <p:nvPr/>
         </p:nvPicPr>
         <p:blipFill>
-          <a:blip r:embed="rId1"/>
+          <a:blip r:embed="rId3"/>
           <a:stretch>
             <a:fillRect/>
           </a:stretch>
@@ -10412,7 +10533,7 @@
             <a:avLst/>
           </a:prstGeom>
           <a:effectLst>
-            <a:outerShdw sx="100000" sy="100000" kx="0" ky="0" algn="bl" rotWithShape="0" blurRad="152400" dist="50800" dir="2700000">
+            <a:outerShdw blurRad="152400" dist="50800" dir="2700000" algn="bl" rotWithShape="0">
               <a:srgbClr val="000000">
                 <a:alpha val="55000"/>
               </a:srgbClr>
@@ -10432,9 +10553,7 @@
             <a:ext cx="384048" cy="256032"/>
           </a:xfrm>
           <a:prstGeom prst="rect">
-            <a:avLst>
-              <a:gd name="adj" fmla="val 14286"/>
-            </a:avLst>
+            <a:avLst/>
           </a:prstGeom>
           <a:solidFill>
             <a:srgbClr val="4ADE80"/>
@@ -10446,6 +10565,13 @@
             <a:prstDash val="solid"/>
           </a:ln>
         </p:spPr>
+        <p:txBody>
+          <a:bodyPr/>
+          <a:lstStyle/>
+          <a:p>
+            <a:endParaRPr lang="es-MX"/>
+          </a:p>
+        </p:txBody>
       </p:sp>
       <p:sp>
         <p:nvSpPr>
@@ -10468,7 +10594,7 @@
           <a:bodyPr wrap="square" rtlCol="0" anchor="ctr"/>
           <a:lstStyle/>
           <a:p>
-            <a:pPr algn="ctr" indent="0" marL="0">
+            <a:pPr marL="0" indent="0" algn="ctr">
               <a:buNone/>
             </a:pPr>
             <a:r>
@@ -10509,7 +10635,7 @@
           </a:bodyPr>
           <a:lstStyle/>
           <a:p>
-            <a:pPr indent="0" marL="0">
+            <a:pPr marL="0" indent="0">
               <a:buNone/>
             </a:pPr>
             <a:r>
@@ -10549,6 +10675,13 @@
             <a:prstDash val="solid"/>
           </a:ln>
         </p:spPr>
+        <p:txBody>
+          <a:bodyPr/>
+          <a:lstStyle/>
+          <a:p>
+            <a:endParaRPr lang="es-MX"/>
+          </a:p>
+        </p:txBody>
       </p:sp>
       <p:sp>
         <p:nvSpPr>
@@ -10571,7 +10704,7 @@
           <a:bodyPr wrap="square" rtlCol="0" anchor="t"/>
           <a:lstStyle/>
           <a:p>
-            <a:pPr indent="0" marL="0">
+            <a:pPr marL="0" indent="0">
               <a:buNone/>
             </a:pPr>
             <a:r>
@@ -10610,7 +10743,7 @@
           <a:bodyPr wrap="square" rtlCol="0" anchor="t"/>
           <a:lstStyle/>
           <a:p>
-            <a:pPr indent="0" marL="0">
+            <a:pPr marL="0" indent="0">
               <a:buNone/>
             </a:pPr>
             <a:r>
@@ -10649,7 +10782,7 @@
           <a:bodyPr wrap="square" rtlCol="0" anchor="t"/>
           <a:lstStyle/>
           <a:p>
-            <a:pPr indent="0" marL="0">
+            <a:pPr marL="0" indent="0">
               <a:buNone/>
             </a:pPr>
             <a:r>
@@ -10688,7 +10821,7 @@
           <a:bodyPr wrap="square" rtlCol="0" anchor="t"/>
           <a:lstStyle/>
           <a:p>
-            <a:pPr indent="0" marL="0">
+            <a:pPr marL="0" indent="0">
               <a:buNone/>
             </a:pPr>
             <a:r>
@@ -10722,6 +10855,7 @@
         <a:solidFill>
           <a:srgbClr val="141929"/>
         </a:solidFill>
+        <a:effectLst/>
       </p:bgPr>
     </p:bg>
     <p:spTree>
@@ -10762,17 +10896,24 @@
             <a:prstDash val="solid"/>
           </a:ln>
         </p:spPr>
+        <p:txBody>
+          <a:bodyPr/>
+          <a:lstStyle/>
+          <a:p>
+            <a:endParaRPr lang="es-MX"/>
+          </a:p>
+        </p:txBody>
       </p:sp>
       <p:pic>
         <p:nvPicPr>
-          <p:cNvPr id="3" name="Image 0" descr="C:\Users\JoseRamonEstradaRend\AppData\Roaming\Claude\local-agent-mode-sessions\skills-plugin\d7d799c7-c68d-4735-9f18-5020fbbe8e77\246afd61-2015-4905-b7d3-2bf63e539570\skills\pptx\screenshots\04_calendario.jpg">    </p:cNvPr>
+          <p:cNvPr id="3" name="Image 0" descr="C:\Users\JoseRamonEstradaRend\AppData\Roaming\Claude\local-agent-mode-sessions\skills-plugin\d7d799c7-c68d-4735-9f18-5020fbbe8e77\246afd61-2015-4905-b7d3-2bf63e539570\skills\pptx\screenshots\04_calendario.jpg"/>
           <p:cNvPicPr>
             <a:picLocks noChangeAspect="1"/>
           </p:cNvPicPr>
           <p:nvPr/>
         </p:nvPicPr>
         <p:blipFill>
-          <a:blip r:embed="rId1"/>
+          <a:blip r:embed="rId3"/>
           <a:stretch>
             <a:fillRect/>
           </a:stretch>
@@ -10786,7 +10927,7 @@
             <a:avLst/>
           </a:prstGeom>
           <a:effectLst>
-            <a:outerShdw sx="100000" sy="100000" kx="0" ky="0" algn="bl" rotWithShape="0" blurRad="152400" dist="50800" dir="2700000">
+            <a:outerShdw blurRad="152400" dist="50800" dir="2700000" algn="bl" rotWithShape="0">
               <a:srgbClr val="000000">
                 <a:alpha val="55000"/>
               </a:srgbClr>
@@ -10806,9 +10947,7 @@
             <a:ext cx="384048" cy="256032"/>
           </a:xfrm>
           <a:prstGeom prst="rect">
-            <a:avLst>
-              <a:gd name="adj" fmla="val 14286"/>
-            </a:avLst>
+            <a:avLst/>
           </a:prstGeom>
           <a:solidFill>
             <a:srgbClr val="4ADE80"/>
@@ -10820,6 +10959,13 @@
             <a:prstDash val="solid"/>
           </a:ln>
         </p:spPr>
+        <p:txBody>
+          <a:bodyPr/>
+          <a:lstStyle/>
+          <a:p>
+            <a:endParaRPr lang="es-MX"/>
+          </a:p>
+        </p:txBody>
       </p:sp>
       <p:sp>
         <p:nvSpPr>
@@ -10842,7 +10988,7 @@
           <a:bodyPr wrap="square" rtlCol="0" anchor="ctr"/>
           <a:lstStyle/>
           <a:p>
-            <a:pPr algn="ctr" indent="0" marL="0">
+            <a:pPr marL="0" indent="0" algn="ctr">
               <a:buNone/>
             </a:pPr>
             <a:r>
@@ -10883,7 +11029,7 @@
           </a:bodyPr>
           <a:lstStyle/>
           <a:p>
-            <a:pPr indent="0" marL="0">
+            <a:pPr marL="0" indent="0">
               <a:buNone/>
             </a:pPr>
             <a:r>
@@ -10923,6 +11069,13 @@
             <a:prstDash val="solid"/>
           </a:ln>
         </p:spPr>
+        <p:txBody>
+          <a:bodyPr/>
+          <a:lstStyle/>
+          <a:p>
+            <a:endParaRPr lang="es-MX"/>
+          </a:p>
+        </p:txBody>
       </p:sp>
       <p:sp>
         <p:nvSpPr>
@@ -10945,7 +11098,7 @@
           <a:bodyPr wrap="square" rtlCol="0" anchor="t"/>
           <a:lstStyle/>
           <a:p>
-            <a:pPr indent="0" marL="0">
+            <a:pPr marL="0" indent="0">
               <a:buNone/>
             </a:pPr>
             <a:r>
@@ -10984,7 +11137,7 @@
           <a:bodyPr wrap="square" rtlCol="0" anchor="t"/>
           <a:lstStyle/>
           <a:p>
-            <a:pPr indent="0" marL="0">
+            <a:pPr marL="0" indent="0">
               <a:buNone/>
             </a:pPr>
             <a:r>
@@ -11023,7 +11176,7 @@
           <a:bodyPr wrap="square" rtlCol="0" anchor="t"/>
           <a:lstStyle/>
           <a:p>
-            <a:pPr indent="0" marL="0">
+            <a:pPr marL="0" indent="0">
               <a:buNone/>
             </a:pPr>
             <a:r>
@@ -11062,7 +11215,7 @@
           <a:bodyPr wrap="square" rtlCol="0" anchor="t"/>
           <a:lstStyle/>
           <a:p>
-            <a:pPr indent="0" marL="0">
+            <a:pPr marL="0" indent="0">
               <a:buNone/>
             </a:pPr>
             <a:r>
@@ -11096,6 +11249,7 @@
         <a:solidFill>
           <a:srgbClr val="141929"/>
         </a:solidFill>
+        <a:effectLst/>
       </p:bgPr>
     </p:bg>
     <p:spTree>
@@ -11136,17 +11290,24 @@
             <a:prstDash val="solid"/>
           </a:ln>
         </p:spPr>
+        <p:txBody>
+          <a:bodyPr/>
+          <a:lstStyle/>
+          <a:p>
+            <a:endParaRPr lang="es-MX"/>
+          </a:p>
+        </p:txBody>
       </p:sp>
       <p:pic>
         <p:nvPicPr>
-          <p:cNvPr id="3" name="Image 0" descr="C:\Users\JoseRamonEstradaRend\AppData\Roaming\Claude\local-agent-mode-sessions\skills-plugin\d7d799c7-c68d-4735-9f18-5020fbbe8e77\246afd61-2015-4905-b7d3-2bf63e539570\skills\pptx\screenshots\06_mapa.jpg">    </p:cNvPr>
+          <p:cNvPr id="3" name="Image 0" descr="C:\Users\JoseRamonEstradaRend\AppData\Roaming\Claude\local-agent-mode-sessions\skills-plugin\d7d799c7-c68d-4735-9f18-5020fbbe8e77\246afd61-2015-4905-b7d3-2bf63e539570\skills\pptx\screenshots\06_mapa.jpg"/>
           <p:cNvPicPr>
             <a:picLocks noChangeAspect="1"/>
           </p:cNvPicPr>
           <p:nvPr/>
         </p:nvPicPr>
         <p:blipFill>
-          <a:blip r:embed="rId1"/>
+          <a:blip r:embed="rId3"/>
           <a:stretch>
             <a:fillRect/>
           </a:stretch>
@@ -11160,7 +11321,7 @@
             <a:avLst/>
           </a:prstGeom>
           <a:effectLst>
-            <a:outerShdw sx="100000" sy="100000" kx="0" ky="0" algn="bl" rotWithShape="0" blurRad="152400" dist="50800" dir="2700000">
+            <a:outerShdw blurRad="152400" dist="50800" dir="2700000" algn="bl" rotWithShape="0">
               <a:srgbClr val="000000">
                 <a:alpha val="55000"/>
               </a:srgbClr>
@@ -11180,9 +11341,7 @@
             <a:ext cx="384048" cy="256032"/>
           </a:xfrm>
           <a:prstGeom prst="rect">
-            <a:avLst>
-              <a:gd name="adj" fmla="val 14286"/>
-            </a:avLst>
+            <a:avLst/>
           </a:prstGeom>
           <a:solidFill>
             <a:srgbClr val="4ADE80"/>
@@ -11194,6 +11353,13 @@
             <a:prstDash val="solid"/>
           </a:ln>
         </p:spPr>
+        <p:txBody>
+          <a:bodyPr/>
+          <a:lstStyle/>
+          <a:p>
+            <a:endParaRPr lang="es-MX"/>
+          </a:p>
+        </p:txBody>
       </p:sp>
       <p:sp>
         <p:nvSpPr>
@@ -11216,7 +11382,7 @@
           <a:bodyPr wrap="square" rtlCol="0" anchor="ctr"/>
           <a:lstStyle/>
           <a:p>
-            <a:pPr algn="ctr" indent="0" marL="0">
+            <a:pPr marL="0" indent="0" algn="ctr">
               <a:buNone/>
             </a:pPr>
             <a:r>
@@ -11257,7 +11423,7 @@
           </a:bodyPr>
           <a:lstStyle/>
           <a:p>
-            <a:pPr indent="0" marL="0">
+            <a:pPr marL="0" indent="0">
               <a:buNone/>
             </a:pPr>
             <a:r>
@@ -11297,6 +11463,13 @@
             <a:prstDash val="solid"/>
           </a:ln>
         </p:spPr>
+        <p:txBody>
+          <a:bodyPr/>
+          <a:lstStyle/>
+          <a:p>
+            <a:endParaRPr lang="es-MX"/>
+          </a:p>
+        </p:txBody>
       </p:sp>
       <p:sp>
         <p:nvSpPr>
@@ -11319,7 +11492,7 @@
           <a:bodyPr wrap="square" rtlCol="0" anchor="t"/>
           <a:lstStyle/>
           <a:p>
-            <a:pPr indent="0" marL="0">
+            <a:pPr marL="0" indent="0">
               <a:buNone/>
             </a:pPr>
             <a:r>
@@ -11358,7 +11531,7 @@
           <a:bodyPr wrap="square" rtlCol="0" anchor="t"/>
           <a:lstStyle/>
           <a:p>
-            <a:pPr indent="0" marL="0">
+            <a:pPr marL="0" indent="0">
               <a:buNone/>
             </a:pPr>
             <a:r>
@@ -11397,7 +11570,7 @@
           <a:bodyPr wrap="square" rtlCol="0" anchor="t"/>
           <a:lstStyle/>
           <a:p>
-            <a:pPr indent="0" marL="0">
+            <a:pPr marL="0" indent="0">
               <a:buNone/>
             </a:pPr>
             <a:r>
@@ -11436,7 +11609,7 @@
           <a:bodyPr wrap="square" rtlCol="0" anchor="t"/>
           <a:lstStyle/>
           <a:p>
-            <a:pPr indent="0" marL="0">
+            <a:pPr marL="0" indent="0">
               <a:buNone/>
             </a:pPr>
             <a:r>
@@ -11470,6 +11643,7 @@
         <a:solidFill>
           <a:srgbClr val="141929"/>
         </a:solidFill>
+        <a:effectLst/>
       </p:bgPr>
     </p:bg>
     <p:spTree>
@@ -11510,17 +11684,24 @@
             <a:prstDash val="solid"/>
           </a:ln>
         </p:spPr>
+        <p:txBody>
+          <a:bodyPr/>
+          <a:lstStyle/>
+          <a:p>
+            <a:endParaRPr lang="es-MX"/>
+          </a:p>
+        </p:txBody>
       </p:sp>
       <p:pic>
         <p:nvPicPr>
-          <p:cNvPr id="3" name="Image 0" descr="C:\Users\JoseRamonEstradaRend\AppData\Roaming\Claude\local-agent-mode-sessions\skills-plugin\d7d799c7-c68d-4735-9f18-5020fbbe8e77\246afd61-2015-4905-b7d3-2bf63e539570\skills\pptx\screenshots\07_organigrama.jpg">    </p:cNvPr>
+          <p:cNvPr id="3" name="Image 0" descr="C:\Users\JoseRamonEstradaRend\AppData\Roaming\Claude\local-agent-mode-sessions\skills-plugin\d7d799c7-c68d-4735-9f18-5020fbbe8e77\246afd61-2015-4905-b7d3-2bf63e539570\skills\pptx\screenshots\07_organigrama.jpg"/>
           <p:cNvPicPr>
             <a:picLocks noChangeAspect="1"/>
           </p:cNvPicPr>
           <p:nvPr/>
         </p:nvPicPr>
         <p:blipFill>
-          <a:blip r:embed="rId1"/>
+          <a:blip r:embed="rId3"/>
           <a:stretch>
             <a:fillRect/>
           </a:stretch>
@@ -11534,7 +11715,7 @@
             <a:avLst/>
           </a:prstGeom>
           <a:effectLst>
-            <a:outerShdw sx="100000" sy="100000" kx="0" ky="0" algn="bl" rotWithShape="0" blurRad="152400" dist="50800" dir="2700000">
+            <a:outerShdw blurRad="152400" dist="50800" dir="2700000" algn="bl" rotWithShape="0">
               <a:srgbClr val="000000">
                 <a:alpha val="55000"/>
               </a:srgbClr>
@@ -11554,9 +11735,7 @@
             <a:ext cx="384048" cy="256032"/>
           </a:xfrm>
           <a:prstGeom prst="rect">
-            <a:avLst>
-              <a:gd name="adj" fmla="val 14286"/>
-            </a:avLst>
+            <a:avLst/>
           </a:prstGeom>
           <a:solidFill>
             <a:srgbClr val="4ADE80"/>
@@ -11568,6 +11747,13 @@
             <a:prstDash val="solid"/>
           </a:ln>
         </p:spPr>
+        <p:txBody>
+          <a:bodyPr/>
+          <a:lstStyle/>
+          <a:p>
+            <a:endParaRPr lang="es-MX"/>
+          </a:p>
+        </p:txBody>
       </p:sp>
       <p:sp>
         <p:nvSpPr>
@@ -11590,7 +11776,7 @@
           <a:bodyPr wrap="square" rtlCol="0" anchor="ctr"/>
           <a:lstStyle/>
           <a:p>
-            <a:pPr algn="ctr" indent="0" marL="0">
+            <a:pPr marL="0" indent="0" algn="ctr">
               <a:buNone/>
             </a:pPr>
             <a:r>
@@ -11631,7 +11817,7 @@
           </a:bodyPr>
           <a:lstStyle/>
           <a:p>
-            <a:pPr indent="0" marL="0">
+            <a:pPr marL="0" indent="0">
               <a:buNone/>
             </a:pPr>
             <a:r>
@@ -11671,6 +11857,13 @@
             <a:prstDash val="solid"/>
           </a:ln>
         </p:spPr>
+        <p:txBody>
+          <a:bodyPr/>
+          <a:lstStyle/>
+          <a:p>
+            <a:endParaRPr lang="es-MX"/>
+          </a:p>
+        </p:txBody>
       </p:sp>
       <p:sp>
         <p:nvSpPr>
@@ -11693,7 +11886,7 @@
           <a:bodyPr wrap="square" rtlCol="0" anchor="t"/>
           <a:lstStyle/>
           <a:p>
-            <a:pPr indent="0" marL="0">
+            <a:pPr marL="0" indent="0">
               <a:buNone/>
             </a:pPr>
             <a:r>
@@ -11732,7 +11925,7 @@
           <a:bodyPr wrap="square" rtlCol="0" anchor="t"/>
           <a:lstStyle/>
           <a:p>
-            <a:pPr indent="0" marL="0">
+            <a:pPr marL="0" indent="0">
               <a:buNone/>
             </a:pPr>
             <a:r>
@@ -11771,7 +11964,7 @@
           <a:bodyPr wrap="square" rtlCol="0" anchor="t"/>
           <a:lstStyle/>
           <a:p>
-            <a:pPr indent="0" marL="0">
+            <a:pPr marL="0" indent="0">
               <a:buNone/>
             </a:pPr>
             <a:r>
@@ -11810,7 +12003,7 @@
           <a:bodyPr wrap="square" rtlCol="0" anchor="t"/>
           <a:lstStyle/>
           <a:p>
-            <a:pPr indent="0" marL="0">
+            <a:pPr marL="0" indent="0">
               <a:buNone/>
             </a:pPr>
             <a:r>
@@ -11844,6 +12037,7 @@
         <a:solidFill>
           <a:srgbClr val="141929"/>
         </a:solidFill>
+        <a:effectLst/>
       </p:bgPr>
     </p:bg>
     <p:spTree>
@@ -11884,17 +12078,24 @@
             <a:prstDash val="solid"/>
           </a:ln>
         </p:spPr>
+        <p:txBody>
+          <a:bodyPr/>
+          <a:lstStyle/>
+          <a:p>
+            <a:endParaRPr lang="es-MX"/>
+          </a:p>
+        </p:txBody>
       </p:sp>
       <p:pic>
         <p:nvPicPr>
-          <p:cNvPr id="3" name="Image 0" descr="C:\Users\JoseRamonEstradaRend\AppData\Roaming\Claude\local-agent-mode-sessions\skills-plugin\d7d799c7-c68d-4735-9f18-5020fbbe8e77\246afd61-2015-4905-b7d3-2bf63e539570\skills\pptx\screenshots\10_empleados.jpg">    </p:cNvPr>
+          <p:cNvPr id="3" name="Image 0" descr="C:\Users\JoseRamonEstradaRend\AppData\Roaming\Claude\local-agent-mode-sessions\skills-plugin\d7d799c7-c68d-4735-9f18-5020fbbe8e77\246afd61-2015-4905-b7d3-2bf63e539570\skills\pptx\screenshots\10_empleados.jpg"/>
           <p:cNvPicPr>
             <a:picLocks noChangeAspect="1"/>
           </p:cNvPicPr>
           <p:nvPr/>
         </p:nvPicPr>
         <p:blipFill>
-          <a:blip r:embed="rId1"/>
+          <a:blip r:embed="rId3"/>
           <a:stretch>
             <a:fillRect/>
           </a:stretch>
@@ -11908,7 +12109,7 @@
             <a:avLst/>
           </a:prstGeom>
           <a:effectLst>
-            <a:outerShdw sx="100000" sy="100000" kx="0" ky="0" algn="bl" rotWithShape="0" blurRad="152400" dist="50800" dir="2700000">
+            <a:outerShdw blurRad="152400" dist="50800" dir="2700000" algn="bl" rotWithShape="0">
               <a:srgbClr val="000000">
                 <a:alpha val="55000"/>
               </a:srgbClr>
@@ -11928,9 +12129,7 @@
             <a:ext cx="384048" cy="256032"/>
           </a:xfrm>
           <a:prstGeom prst="rect">
-            <a:avLst>
-              <a:gd name="adj" fmla="val 14286"/>
-            </a:avLst>
+            <a:avLst/>
           </a:prstGeom>
           <a:solidFill>
             <a:srgbClr val="4ADE80"/>
@@ -11942,6 +12141,13 @@
             <a:prstDash val="solid"/>
           </a:ln>
         </p:spPr>
+        <p:txBody>
+          <a:bodyPr/>
+          <a:lstStyle/>
+          <a:p>
+            <a:endParaRPr lang="es-MX"/>
+          </a:p>
+        </p:txBody>
       </p:sp>
       <p:sp>
         <p:nvSpPr>
@@ -11964,7 +12170,7 @@
           <a:bodyPr wrap="square" rtlCol="0" anchor="ctr"/>
           <a:lstStyle/>
           <a:p>
-            <a:pPr algn="ctr" indent="0" marL="0">
+            <a:pPr marL="0" indent="0" algn="ctr">
               <a:buNone/>
             </a:pPr>
             <a:r>
@@ -12005,7 +12211,7 @@
           </a:bodyPr>
           <a:lstStyle/>
           <a:p>
-            <a:pPr indent="0" marL="0">
+            <a:pPr marL="0" indent="0">
               <a:buNone/>
             </a:pPr>
             <a:r>
@@ -12045,6 +12251,13 @@
             <a:prstDash val="solid"/>
           </a:ln>
         </p:spPr>
+        <p:txBody>
+          <a:bodyPr/>
+          <a:lstStyle/>
+          <a:p>
+            <a:endParaRPr lang="es-MX"/>
+          </a:p>
+        </p:txBody>
       </p:sp>
       <p:sp>
         <p:nvSpPr>
@@ -12067,7 +12280,7 @@
           <a:bodyPr wrap="square" rtlCol="0" anchor="t"/>
           <a:lstStyle/>
           <a:p>
-            <a:pPr indent="0" marL="0">
+            <a:pPr marL="0" indent="0">
               <a:buNone/>
             </a:pPr>
             <a:r>
@@ -12106,7 +12319,7 @@
           <a:bodyPr wrap="square" rtlCol="0" anchor="t"/>
           <a:lstStyle/>
           <a:p>
-            <a:pPr indent="0" marL="0">
+            <a:pPr marL="0" indent="0">
               <a:buNone/>
             </a:pPr>
             <a:r>
@@ -12145,7 +12358,7 @@
           <a:bodyPr wrap="square" rtlCol="0" anchor="t"/>
           <a:lstStyle/>
           <a:p>
-            <a:pPr indent="0" marL="0">
+            <a:pPr marL="0" indent="0">
               <a:buNone/>
             </a:pPr>
             <a:r>
@@ -12184,7 +12397,7 @@
           <a:bodyPr wrap="square" rtlCol="0" anchor="t"/>
           <a:lstStyle/>
           <a:p>
-            <a:pPr indent="0" marL="0">
+            <a:pPr marL="0" indent="0">
               <a:buNone/>
             </a:pPr>
             <a:r>
@@ -12503,4 +12716,325 @@
     </a:ext>
   </a:extLst>
 </a:theme>
+</file>
+
+<file path=ppt/theme/theme2.xml><?xml version="1.0" encoding="utf-8"?>
+<a:theme xmlns:a="http://schemas.openxmlformats.org/drawingml/2006/main" name="Tema de Office">
+  <a:themeElements>
+    <a:clrScheme name="Office">
+      <a:dk1>
+        <a:sysClr val="windowText" lastClr="000000"/>
+      </a:dk1>
+      <a:lt1>
+        <a:sysClr val="window" lastClr="FFFFFF"/>
+      </a:lt1>
+      <a:dk2>
+        <a:srgbClr val="0E2841"/>
+      </a:dk2>
+      <a:lt2>
+        <a:srgbClr val="E8E8E8"/>
+      </a:lt2>
+      <a:accent1>
+        <a:srgbClr val="156082"/>
+      </a:accent1>
+      <a:accent2>
+        <a:srgbClr val="E97132"/>
+      </a:accent2>
+      <a:accent3>
+        <a:srgbClr val="196B24"/>
+      </a:accent3>
+      <a:accent4>
+        <a:srgbClr val="0F9ED5"/>
+      </a:accent4>
+      <a:accent5>
+        <a:srgbClr val="A02B93"/>
+      </a:accent5>
+      <a:accent6>
+        <a:srgbClr val="4EA72E"/>
+      </a:accent6>
+      <a:hlink>
+        <a:srgbClr val="467886"/>
+      </a:hlink>
+      <a:folHlink>
+        <a:srgbClr val="96607D"/>
+      </a:folHlink>
+    </a:clrScheme>
+    <a:fontScheme name="Office">
+      <a:majorFont>
+        <a:latin typeface="Aptos Display" panose="02110004020202020204"/>
+        <a:ea typeface=""/>
+        <a:cs typeface=""/>
+        <a:font script="Jpan" typeface="游ゴシック Light"/>
+        <a:font script="Hang" typeface="맑은 고딕"/>
+        <a:font script="Hans" typeface="等线 Light"/>
+        <a:font script="Hant" typeface="新細明體"/>
+        <a:font script="Arab" typeface="Times New Roman"/>
+        <a:font script="Hebr" typeface="Times New Roman"/>
+        <a:font script="Thai" typeface="Angsana New"/>
+        <a:font script="Ethi" typeface="Nyala"/>
+        <a:font script="Beng" typeface="Vrinda"/>
+        <a:font script="Gujr" typeface="Shruti"/>
+        <a:font script="Khmr" typeface="MoolBoran"/>
+        <a:font script="Knda" typeface="Tunga"/>
+        <a:font script="Guru" typeface="Raavi"/>
+        <a:font script="Cans" typeface="Euphemia"/>
+        <a:font script="Cher" typeface="Plantagenet Cherokee"/>
+        <a:font script="Yiii" typeface="Microsoft Yi Baiti"/>
+        <a:font script="Tibt" typeface="Microsoft Himalaya"/>
+        <a:font script="Thaa" typeface="MV Boli"/>
+        <a:font script="Deva" typeface="Mangal"/>
+        <a:font script="Telu" typeface="Gautami"/>
+        <a:font script="Taml" typeface="Latha"/>
+        <a:font script="Syrc" typeface="Estrangelo Edessa"/>
+        <a:font script="Orya" typeface="Kalinga"/>
+        <a:font script="Mlym" typeface="Kartika"/>
+        <a:font script="Laoo" typeface="DokChampa"/>
+        <a:font script="Sinh" typeface="Iskoola Pota"/>
+        <a:font script="Mong" typeface="Mongolian Baiti"/>
+        <a:font script="Viet" typeface="Times New Roman"/>
+        <a:font script="Uigh" typeface="Microsoft Uighur"/>
+        <a:font script="Geor" typeface="Sylfaen"/>
+        <a:font script="Armn" typeface="Arial"/>
+        <a:font script="Bugi" typeface="Leelawadee UI"/>
+        <a:font script="Bopo" typeface="Microsoft JhengHei"/>
+        <a:font script="Java" typeface="Javanese Text"/>
+        <a:font script="Lisu" typeface="Segoe UI"/>
+        <a:font script="Mymr" typeface="Myanmar Text"/>
+        <a:font script="Nkoo" typeface="Ebrima"/>
+        <a:font script="Olck" typeface="Nirmala UI"/>
+        <a:font script="Osma" typeface="Ebrima"/>
+        <a:font script="Phag" typeface="Phagspa"/>
+        <a:font script="Syrn" typeface="Estrangelo Edessa"/>
+        <a:font script="Syrj" typeface="Estrangelo Edessa"/>
+        <a:font script="Syre" typeface="Estrangelo Edessa"/>
+        <a:font script="Sora" typeface="Nirmala UI"/>
+        <a:font script="Tale" typeface="Microsoft Tai Le"/>
+        <a:font script="Talu" typeface="Microsoft New Tai Lue"/>
+        <a:font script="Tfng" typeface="Ebrima"/>
+      </a:majorFont>
+      <a:minorFont>
+        <a:latin typeface="Aptos" panose="02110004020202020204"/>
+        <a:ea typeface=""/>
+        <a:cs typeface=""/>
+        <a:font script="Jpan" typeface="游ゴシック"/>
+        <a:font script="Hang" typeface="맑은 고딕"/>
+        <a:font script="Hans" typeface="等线"/>
+        <a:font script="Hant" typeface="新細明體"/>
+        <a:font script="Arab" typeface="Arial"/>
+        <a:font script="Hebr" typeface="Arial"/>
+        <a:font script="Thai" typeface="Cordia New"/>
+        <a:font script="Ethi" typeface="Nyala"/>
+        <a:font script="Beng" typeface="Vrinda"/>
+        <a:font script="Gujr" typeface="Shruti"/>
+        <a:font script="Khmr" typeface="DaunPenh"/>
+        <a:font script="Knda" typeface="Tunga"/>
+        <a:font script="Guru" typeface="Raavi"/>
+        <a:font script="Cans" typeface="Euphemia"/>
+        <a:font script="Cher" typeface="Plantagenet Cherokee"/>
+        <a:font script="Yiii" typeface="Microsoft Yi Baiti"/>
+        <a:font script="Tibt" typeface="Microsoft Himalaya"/>
+        <a:font script="Thaa" typeface="MV Boli"/>
+        <a:font script="Deva" typeface="Mangal"/>
+        <a:font script="Telu" typeface="Gautami"/>
+        <a:font script="Taml" typeface="Latha"/>
+        <a:font script="Syrc" typeface="Estrangelo Edessa"/>
+        <a:font script="Orya" typeface="Kalinga"/>
+        <a:font script="Mlym" typeface="Kartika"/>
+        <a:font script="Laoo" typeface="DokChampa"/>
+        <a:font script="Sinh" typeface="Iskoola Pota"/>
+        <a:font script="Mong" typeface="Mongolian Baiti"/>
+        <a:font script="Viet" typeface="Arial"/>
+        <a:font script="Uigh" typeface="Microsoft Uighur"/>
+        <a:font script="Geor" typeface="Sylfaen"/>
+        <a:font script="Armn" typeface="Arial"/>
+        <a:font script="Bugi" typeface="Leelawadee UI"/>
+        <a:font script="Bopo" typeface="Microsoft JhengHei"/>
+        <a:font script="Java" typeface="Javanese Text"/>
+        <a:font script="Lisu" typeface="Segoe UI"/>
+        <a:font script="Mymr" typeface="Myanmar Text"/>
+        <a:font script="Nkoo" typeface="Ebrima"/>
+        <a:font script="Olck" typeface="Nirmala UI"/>
+        <a:font script="Osma" typeface="Ebrima"/>
+        <a:font script="Phag" typeface="Phagspa"/>
+        <a:font script="Syrn" typeface="Estrangelo Edessa"/>
+        <a:font script="Syrj" typeface="Estrangelo Edessa"/>
+        <a:font script="Syre" typeface="Estrangelo Edessa"/>
+        <a:font script="Sora" typeface="Nirmala UI"/>
+        <a:font script="Tale" typeface="Microsoft Tai Le"/>
+        <a:font script="Talu" typeface="Microsoft New Tai Lue"/>
+        <a:font script="Tfng" typeface="Ebrima"/>
+      </a:minorFont>
+    </a:fontScheme>
+    <a:fmtScheme name="Office">
+      <a:fillStyleLst>
+        <a:solidFill>
+          <a:schemeClr val="phClr"/>
+        </a:solidFill>
+        <a:gradFill rotWithShape="1">
+          <a:gsLst>
+            <a:gs pos="0">
+              <a:schemeClr val="phClr">
+                <a:lumMod val="110000"/>
+                <a:satMod val="105000"/>
+                <a:tint val="67000"/>
+              </a:schemeClr>
+            </a:gs>
+            <a:gs pos="50000">
+              <a:schemeClr val="phClr">
+                <a:lumMod val="105000"/>
+                <a:satMod val="103000"/>
+                <a:tint val="73000"/>
+              </a:schemeClr>
+            </a:gs>
+            <a:gs pos="100000">
+              <a:schemeClr val="phClr">
+                <a:lumMod val="105000"/>
+                <a:satMod val="109000"/>
+                <a:tint val="81000"/>
+              </a:schemeClr>
+            </a:gs>
+          </a:gsLst>
+          <a:lin ang="5400000" scaled="0"/>
+        </a:gradFill>
+        <a:gradFill rotWithShape="1">
+          <a:gsLst>
+            <a:gs pos="0">
+              <a:schemeClr val="phClr">
+                <a:satMod val="103000"/>
+                <a:lumMod val="102000"/>
+                <a:tint val="94000"/>
+              </a:schemeClr>
+            </a:gs>
+            <a:gs pos="50000">
+              <a:schemeClr val="phClr">
+                <a:satMod val="110000"/>
+                <a:lumMod val="100000"/>
+                <a:shade val="100000"/>
+              </a:schemeClr>
+            </a:gs>
+            <a:gs pos="100000">
+              <a:schemeClr val="phClr">
+                <a:lumMod val="99000"/>
+                <a:satMod val="120000"/>
+                <a:shade val="78000"/>
+              </a:schemeClr>
+            </a:gs>
+          </a:gsLst>
+          <a:lin ang="5400000" scaled="0"/>
+        </a:gradFill>
+      </a:fillStyleLst>
+      <a:lnStyleLst>
+        <a:ln w="12700" cap="flat" cmpd="sng" algn="ctr">
+          <a:solidFill>
+            <a:schemeClr val="phClr"/>
+          </a:solidFill>
+          <a:prstDash val="solid"/>
+          <a:miter lim="800000"/>
+        </a:ln>
+        <a:ln w="19050" cap="flat" cmpd="sng" algn="ctr">
+          <a:solidFill>
+            <a:schemeClr val="phClr"/>
+          </a:solidFill>
+          <a:prstDash val="solid"/>
+          <a:miter lim="800000"/>
+        </a:ln>
+        <a:ln w="25400" cap="flat" cmpd="sng" algn="ctr">
+          <a:solidFill>
+            <a:schemeClr val="phClr"/>
+          </a:solidFill>
+          <a:prstDash val="solid"/>
+          <a:miter lim="800000"/>
+        </a:ln>
+      </a:lnStyleLst>
+      <a:effectStyleLst>
+        <a:effectStyle>
+          <a:effectLst/>
+        </a:effectStyle>
+        <a:effectStyle>
+          <a:effectLst/>
+        </a:effectStyle>
+        <a:effectStyle>
+          <a:effectLst>
+            <a:outerShdw blurRad="57150" dist="19050" dir="5400000" algn="ctr" rotWithShape="0">
+              <a:srgbClr val="000000">
+                <a:alpha val="63000"/>
+              </a:srgbClr>
+            </a:outerShdw>
+          </a:effectLst>
+        </a:effectStyle>
+      </a:effectStyleLst>
+      <a:bgFillStyleLst>
+        <a:solidFill>
+          <a:schemeClr val="phClr"/>
+        </a:solidFill>
+        <a:solidFill>
+          <a:schemeClr val="phClr">
+            <a:tint val="95000"/>
+            <a:satMod val="170000"/>
+          </a:schemeClr>
+        </a:solidFill>
+        <a:gradFill rotWithShape="1">
+          <a:gsLst>
+            <a:gs pos="0">
+              <a:schemeClr val="phClr">
+                <a:tint val="93000"/>
+                <a:satMod val="150000"/>
+                <a:shade val="98000"/>
+                <a:lumMod val="102000"/>
+              </a:schemeClr>
+            </a:gs>
+            <a:gs pos="50000">
+              <a:schemeClr val="phClr">
+                <a:tint val="98000"/>
+                <a:satMod val="130000"/>
+                <a:shade val="90000"/>
+                <a:lumMod val="103000"/>
+              </a:schemeClr>
+            </a:gs>
+            <a:gs pos="100000">
+              <a:schemeClr val="phClr">
+                <a:shade val="63000"/>
+                <a:satMod val="120000"/>
+              </a:schemeClr>
+            </a:gs>
+          </a:gsLst>
+          <a:lin ang="5400000" scaled="0"/>
+        </a:gradFill>
+      </a:bgFillStyleLst>
+    </a:fmtScheme>
+  </a:themeElements>
+  <a:objectDefaults>
+    <a:lnDef>
+      <a:spPr/>
+      <a:bodyPr/>
+      <a:lstStyle/>
+      <a:style>
+        <a:lnRef idx="2">
+          <a:schemeClr val="accent1"/>
+        </a:lnRef>
+        <a:fillRef idx="0">
+          <a:schemeClr val="accent1"/>
+        </a:fillRef>
+        <a:effectRef idx="1">
+          <a:schemeClr val="accent1"/>
+        </a:effectRef>
+        <a:fontRef idx="minor">
+          <a:schemeClr val="tx1"/>
+        </a:fontRef>
+      </a:style>
+    </a:lnDef>
+  </a:objectDefaults>
+  <a:extraClrSchemeLst/>
+  <a:extLst>
+    <a:ext uri="{05A4C25C-085E-4340-85A3-A5531E510DB2}">
+      <thm15:themeFamily xmlns:thm15="http://schemas.microsoft.com/office/thememl/2012/main" name="Office Theme" id="{2E142A2C-CD16-42D6-873A-C26D2A0506FA}" vid="{1BDDFF52-6CD6-40A5-AB3C-68EB2F1E4D0A}"/>
+    </a:ext>
+  </a:extLst>
+</a:theme>
+</file>
+
+<file path=docMetadata/LabelInfo.xml><?xml version="1.0" encoding="utf-8"?>
+<clbl:labelList xmlns:clbl="http://schemas.microsoft.com/office/2020/mipLabelMetadata">
+  <clbl:label id="{4d305a54-e534-44b8-89b6-47b6ad9af26a}" enabled="1" method="Privileged" siteId="{6e6b996f-b0c6-433e-81f0-3873ef06b338}" contentBits="0" removed="0"/>
+</clbl:labelList>
 </file>
</xml_diff>